<commit_message>
update sample output, slide, image and diagram
</commit_message>
<xml_diff>
--- a/docs/Slide.pptx
+++ b/docs/Slide.pptx
@@ -136,7 +136,17 @@
   <c:chart>
     <c:autoTitleDeleted val="1"/>
     <c:plotArea>
-      <c:layout/>
+      <c:layout>
+        <c:manualLayout>
+          <c:layoutTarget val="inner"/>
+          <c:xMode val="edge"/>
+          <c:yMode val="edge"/>
+          <c:x val="0.0337641025641026"/>
+          <c:y val="0.0466666666666667"/>
+          <c:w val="0.936492307692308"/>
+          <c:h val="0.860717948717949"/>
+        </c:manualLayout>
+      </c:layout>
       <c:barChart>
         <c:barDir val="col"/>
         <c:grouping val="clustered"/>
@@ -162,6 +172,41 @@
           </c:spPr>
           <c:invertIfNegative val="0"/>
           <c:dLbls>
+            <c:dLbl>
+              <c:idx val="1"/>
+              <c:layout/>
+              <c:tx>
+                <c:rich>
+                  <a:bodyPr rot="0" spcFirstLastPara="0" vertOverflow="ellipsis" vert="horz" wrap="square" lIns="38100" tIns="19050" rIns="38100" bIns="19050" anchor="ctr" anchorCtr="1"/>
+                  <a:lstStyle/>
+                  <a:p>
+                    <a:pPr defTabSz="914400">
+                      <a:defRPr lang="en-US" sz="1000" b="0" i="0" u="none" strike="noStrike" kern="1200" baseline="0">
+                        <a:solidFill>
+                          <a:schemeClr val="tx1"/>
+                        </a:solidFill>
+                        <a:latin typeface="+mn-lt"/>
+                        <a:ea typeface="+mn-ea"/>
+                        <a:cs typeface="+mn-cs"/>
+                      </a:defRPr>
+                    </a:pPr>
+                    <a:r>
+                      <a:t>3.5</a:t>
+                    </a:r>
+                  </a:p>
+                </c:rich>
+              </c:tx>
+              <c:dLblPos val="outEnd"/>
+              <c:showLegendKey val="0"/>
+              <c:showVal val="1"/>
+              <c:showCatName val="0"/>
+              <c:showSerName val="0"/>
+              <c:showPercent val="0"/>
+              <c:showBubbleSize val="0"/>
+              <c:extLst>
+                <c:ext xmlns:c15="http://schemas.microsoft.com/office/drawing/2012/chart" uri="{CE6537A1-D6FC-4f65-9D91-7224C49458BB}"/>
+              </c:extLst>
+            </c:dLbl>
             <c:numFmt formatCode="General" sourceLinked="1"/>
             <c:spPr>
               <a:noFill/>
@@ -5266,7 +5311,7 @@
           <p:nvPr/>
         </p:nvGraphicFramePr>
         <p:xfrm>
-          <a:off x="552450" y="1952625"/>
+          <a:off x="551180" y="1916430"/>
           <a:ext cx="6191250" cy="3714750"/>
         </p:xfrm>
         <a:graphic>
@@ -5524,9 +5569,20 @@
                 <a:ea typeface="Arial" panose="020B0604020202020204"/>
                 <a:cs typeface="Arial" panose="020B0604020202020204"/>
               </a:rPr>
-              <a:t>33</a:t>
-            </a:r>
-            <a:endParaRPr sz="3000" b="1">
+              <a:t>3</a:t>
+            </a:r>
+            <a:r>
+              <a:rPr lang="en-US" sz="3000" b="1">
+                <a:solidFill>
+                  <a:srgbClr val="111111"/>
+                </a:solidFill>
+                <a:latin typeface="Arial" panose="020B0604020202020204"/>
+                <a:ea typeface="Arial" panose="020B0604020202020204"/>
+                <a:cs typeface="Arial" panose="020B0604020202020204"/>
+              </a:rPr>
+              <a:t>1</a:t>
+            </a:r>
+            <a:endParaRPr lang="en-US" sz="3000" b="1">
               <a:solidFill>
                 <a:srgbClr val="111111"/>
               </a:solidFill>
@@ -5636,7 +5692,7 @@
               </a:defRPr>
             </a:pPr>
             <a:r>
-              <a:rPr sz="3000" b="1">
+              <a:rPr lang="en-US" sz="3000" b="1">
                 <a:solidFill>
                   <a:srgbClr val="111111"/>
                 </a:solidFill>
@@ -5644,9 +5700,9 @@
                 <a:ea typeface="Arial" panose="020B0604020202020204"/>
                 <a:cs typeface="Arial" panose="020B0604020202020204"/>
               </a:rPr>
-              <a:t>30,577</a:t>
-            </a:r>
-            <a:endParaRPr sz="3000" b="1">
+              <a:t>32,394</a:t>
+            </a:r>
+            <a:endParaRPr lang="en-US" sz="3000" b="1">
               <a:solidFill>
                 <a:srgbClr val="111111"/>
               </a:solidFill>
@@ -9772,6 +9828,17 @@
               </a:defRPr>
             </a:pPr>
             <a:r>
+              <a:rPr lang="en-US" sz="1275" b="0">
+                <a:solidFill>
+                  <a:srgbClr val="5F6368"/>
+                </a:solidFill>
+                <a:latin typeface="Arial" panose="020B0604020202020204"/>
+                <a:ea typeface="Arial" panose="020B0604020202020204"/>
+                <a:cs typeface="Arial" panose="020B0604020202020204"/>
+              </a:rPr>
+              <a:t>10</a:t>
+            </a:r>
+            <a:r>
               <a:rPr sz="1275" b="0">
                 <a:solidFill>
                   <a:srgbClr val="5F6368"/>
@@ -9780,7 +9847,7 @@
                 <a:ea typeface="Arial" panose="020B0604020202020204"/>
                 <a:cs typeface="Arial" panose="020B0604020202020204"/>
               </a:rPr>
-              <a:t>7 tên tool</a:t>
+              <a:t> tên tool</a:t>
             </a:r>
             <a:endParaRPr sz="1275" b="0">
               <a:solidFill>
@@ -11645,7 +11712,29 @@
                 <a:ea typeface="Arial" panose="020B0604020202020204"/>
                 <a:cs typeface="Arial" panose="020B0604020202020204"/>
               </a:rPr>
-              <a:t>ToolRegistry quản lý 7 tool ở runtime</a:t>
+              <a:t>ToolRegistry quản lý </a:t>
+            </a:r>
+            <a:r>
+              <a:rPr lang="en-US" sz="2850" b="1">
+                <a:solidFill>
+                  <a:srgbClr val="111111"/>
+                </a:solidFill>
+                <a:latin typeface="Arial" panose="020B0604020202020204"/>
+                <a:ea typeface="Arial" panose="020B0604020202020204"/>
+                <a:cs typeface="Arial" panose="020B0604020202020204"/>
+              </a:rPr>
+              <a:t>10</a:t>
+            </a:r>
+            <a:r>
+              <a:rPr sz="2850" b="1">
+                <a:solidFill>
+                  <a:srgbClr val="111111"/>
+                </a:solidFill>
+                <a:latin typeface="Arial" panose="020B0604020202020204"/>
+                <a:ea typeface="Arial" panose="020B0604020202020204"/>
+                <a:cs typeface="Arial" panose="020B0604020202020204"/>
+              </a:rPr>
+              <a:t> tool ở runtime</a:t>
             </a:r>
             <a:endParaRPr sz="2850" b="1">
               <a:solidFill>
@@ -11757,7 +11846,7 @@
               </a:defRPr>
             </a:pPr>
             <a:r>
-              <a:rPr sz="8400" b="1">
+              <a:rPr lang="en-US" sz="8400" b="1">
                 <a:solidFill>
                   <a:srgbClr val="3D8DFF"/>
                 </a:solidFill>
@@ -11765,9 +11854,9 @@
                 <a:ea typeface="Arial" panose="020B0604020202020204"/>
                 <a:cs typeface="Arial" panose="020B0604020202020204"/>
               </a:rPr>
-              <a:t>7</a:t>
-            </a:r>
-            <a:endParaRPr sz="8400" b="1">
+              <a:t>10</a:t>
+            </a:r>
+            <a:endParaRPr lang="en-US" sz="8400" b="1">
               <a:solidFill>
                 <a:srgbClr val="3D8DFF"/>
               </a:solidFill>
@@ -12195,6 +12284,37 @@
               <a:cs typeface="Arial" panose="020B0604020202020204"/>
             </a:endParaRPr>
           </a:p>
+          <a:p>
+            <a:pPr algn="l">
+              <a:defRPr sz="2100" b="1">
+                <a:solidFill>
+                  <a:srgbClr val="111111"/>
+                </a:solidFill>
+                <a:latin typeface="Arial" panose="020B0604020202020204"/>
+                <a:ea typeface="Arial" panose="020B0604020202020204"/>
+                <a:cs typeface="Arial" panose="020B0604020202020204"/>
+              </a:defRPr>
+            </a:pPr>
+            <a:r>
+              <a:rPr lang="en-US" sz="2100" b="1">
+                <a:solidFill>
+                  <a:srgbClr val="111111"/>
+                </a:solidFill>
+                <a:latin typeface="Arial" panose="020B0604020202020204"/>
+                <a:ea typeface="Arial" panose="020B0604020202020204"/>
+                <a:cs typeface="Arial" panose="020B0604020202020204"/>
+              </a:rPr>
+              <a:t>current_time</a:t>
+            </a:r>
+            <a:endParaRPr lang="en-US" sz="2100" b="1">
+              <a:solidFill>
+                <a:srgbClr val="111111"/>
+              </a:solidFill>
+              <a:latin typeface="Arial" panose="020B0604020202020204"/>
+              <a:ea typeface="Arial" panose="020B0604020202020204"/>
+              <a:cs typeface="Arial" panose="020B0604020202020204"/>
+            </a:endParaRPr>
+          </a:p>
         </p:txBody>
       </p:sp>
       <p:sp>
@@ -12459,6 +12579,37 @@
               <a:cs typeface="Arial" panose="020B0604020202020204"/>
             </a:endParaRPr>
           </a:p>
+          <a:p>
+            <a:pPr algn="l">
+              <a:defRPr sz="2100" b="1">
+                <a:solidFill>
+                  <a:srgbClr val="111111"/>
+                </a:solidFill>
+                <a:latin typeface="Arial" panose="020B0604020202020204"/>
+                <a:ea typeface="Arial" panose="020B0604020202020204"/>
+                <a:cs typeface="Arial" panose="020B0604020202020204"/>
+              </a:defRPr>
+            </a:pPr>
+            <a:r>
+              <a:rPr lang="en-US" sz="2100" b="1">
+                <a:solidFill>
+                  <a:srgbClr val="111111"/>
+                </a:solidFill>
+                <a:latin typeface="Arial" panose="020B0604020202020204"/>
+                <a:ea typeface="Arial" panose="020B0604020202020204"/>
+                <a:cs typeface="Arial" panose="020B0604020202020204"/>
+              </a:rPr>
+              <a:t>json_query</a:t>
+            </a:r>
+            <a:endParaRPr lang="en-US" sz="2100" b="1">
+              <a:solidFill>
+                <a:srgbClr val="111111"/>
+              </a:solidFill>
+              <a:latin typeface="Arial" panose="020B0604020202020204"/>
+              <a:ea typeface="Arial" panose="020B0604020202020204"/>
+              <a:cs typeface="Arial" panose="020B0604020202020204"/>
+            </a:endParaRPr>
+          </a:p>
         </p:txBody>
       </p:sp>
       <p:sp>
@@ -12644,17 +12795,48 @@
             <a:r>
               <a:rPr sz="2100" b="1">
                 <a:solidFill>
+                  <a:schemeClr val="tx1"/>
+                </a:solidFill>
+                <a:latin typeface="Arial" panose="020B0604020202020204"/>
+                <a:ea typeface="Arial" panose="020B0604020202020204"/>
+                <a:cs typeface="Arial" panose="020B0604020202020204"/>
+              </a:rPr>
+              <a:t>calculator</a:t>
+            </a:r>
+            <a:endParaRPr sz="2100" b="1">
+              <a:solidFill>
+                <a:schemeClr val="tx1"/>
+              </a:solidFill>
+              <a:latin typeface="Arial" panose="020B0604020202020204"/>
+              <a:ea typeface="Arial" panose="020B0604020202020204"/>
+              <a:cs typeface="Arial" panose="020B0604020202020204"/>
+            </a:endParaRPr>
+          </a:p>
+          <a:p>
+            <a:pPr algn="l">
+              <a:defRPr sz="2100" b="1">
+                <a:solidFill>
                   <a:srgbClr val="3D8DFF"/>
                 </a:solidFill>
                 <a:latin typeface="Arial" panose="020B0604020202020204"/>
                 <a:ea typeface="Arial" panose="020B0604020202020204"/>
                 <a:cs typeface="Arial" panose="020B0604020202020204"/>
-              </a:rPr>
-              <a:t>calculator</a:t>
-            </a:r>
-            <a:endParaRPr sz="2100" b="1">
-              <a:solidFill>
-                <a:srgbClr val="3D8DFF"/>
+              </a:defRPr>
+            </a:pPr>
+            <a:r>
+              <a:rPr lang="en-US" sz="2100" b="1">
+                <a:solidFill>
+                  <a:schemeClr val="tx1"/>
+                </a:solidFill>
+                <a:latin typeface="Arial" panose="020B0604020202020204"/>
+                <a:ea typeface="Arial" panose="020B0604020202020204"/>
+                <a:cs typeface="Arial" panose="020B0604020202020204"/>
+              </a:rPr>
+              <a:t>text_stats</a:t>
+            </a:r>
+            <a:endParaRPr lang="en-US" sz="2100" b="1">
+              <a:solidFill>
+                <a:schemeClr val="tx1"/>
               </a:solidFill>
               <a:latin typeface="Arial" panose="020B0604020202020204"/>
               <a:ea typeface="Arial" panose="020B0604020202020204"/>

</xml_diff>

<commit_message>
update report and slide
</commit_message>
<xml_diff>
--- a/docs/Slide.pptx
+++ b/docs/Slide.pptx
@@ -134,17 +134,47 @@
     </mc:Fallback>
   </mc:AlternateContent>
   <c:chart>
-    <c:autoTitleDeleted val="1"/>
+    <c:title>
+      <c:layout/>
+      <c:overlay val="0"/>
+      <c:spPr>
+        <a:noFill/>
+        <a:ln>
+          <a:noFill/>
+        </a:ln>
+        <a:effectLst/>
+      </c:spPr>
+      <c:txPr>
+        <a:bodyPr rot="0" spcFirstLastPara="0" vertOverflow="ellipsis" vert="horz" wrap="square" anchor="ctr" anchorCtr="1"/>
+        <a:lstStyle/>
+        <a:p>
+          <a:pPr>
+            <a:defRPr lang="en-US" sz="1400" b="1" i="0" u="none" strike="noStrike" kern="1200" baseline="0">
+              <a:solidFill>
+                <a:schemeClr val="tx1">
+                  <a:lumMod val="75000"/>
+                  <a:lumOff val="25000"/>
+                </a:schemeClr>
+              </a:solidFill>
+              <a:latin typeface="+mn-lt"/>
+              <a:ea typeface="+mn-ea"/>
+              <a:cs typeface="+mn-cs"/>
+            </a:defRPr>
+          </a:pPr>
+        </a:p>
+      </c:txPr>
+    </c:title>
+    <c:autoTitleDeleted val="0"/>
     <c:plotArea>
       <c:layout>
         <c:manualLayout>
           <c:layoutTarget val="inner"/>
           <c:xMode val="edge"/>
           <c:yMode val="edge"/>
-          <c:x val="0.0337641025641026"/>
-          <c:y val="0.0466666666666667"/>
-          <c:w val="0.936492307692308"/>
-          <c:h val="0.860717948717949"/>
+          <c:x val="0.0392349828242503"/>
+          <c:y val="0.122674791533034"/>
+          <c:w val="0.858174728437471"/>
+          <c:h val="0.726812059012187"/>
         </c:manualLayout>
       </c:layout>
       <c:barChart>
@@ -156,102 +186,33 @@
           <c:order val="0"/>
           <c:tx>
             <c:strRef>
-              <c:f>Bước trung bình</c:f>
+              <c:f>Sheet1!$B$1</c:f>
               <c:strCache>
                 <c:ptCount val="1"/>
                 <c:pt idx="0">
-                  <c:v>Bước trung bình</c:v>
+                  <c:v>Trung bình số bước</c:v>
                 </c:pt>
               </c:strCache>
             </c:strRef>
           </c:tx>
           <c:spPr>
             <a:solidFill>
-              <a:srgbClr val="3D8DFF"/>
+              <a:schemeClr val="accent1"/>
             </a:solidFill>
+            <a:ln>
+              <a:noFill/>
+            </a:ln>
+            <a:effectLst/>
           </c:spPr>
           <c:invertIfNegative val="0"/>
           <c:dLbls>
-            <c:dLbl>
-              <c:idx val="1"/>
-              <c:layout/>
-              <c:tx>
-                <c:rich>
-                  <a:bodyPr rot="0" spcFirstLastPara="0" vertOverflow="ellipsis" vert="horz" wrap="square" lIns="38100" tIns="19050" rIns="38100" bIns="19050" anchor="ctr" anchorCtr="1"/>
-                  <a:lstStyle/>
-                  <a:p>
-                    <a:pPr defTabSz="914400">
-                      <a:defRPr lang="en-US" sz="1000" b="0" i="0" u="none" strike="noStrike" kern="1200" baseline="0">
-                        <a:solidFill>
-                          <a:schemeClr val="tx1"/>
-                        </a:solidFill>
-                        <a:latin typeface="+mn-lt"/>
-                        <a:ea typeface="+mn-ea"/>
-                        <a:cs typeface="+mn-cs"/>
-                      </a:defRPr>
-                    </a:pPr>
-                    <a:r>
-                      <a:t>3.5</a:t>
-                    </a:r>
-                  </a:p>
-                </c:rich>
-              </c:tx>
-              <c:dLblPos val="outEnd"/>
-              <c:showLegendKey val="0"/>
-              <c:showVal val="1"/>
-              <c:showCatName val="0"/>
-              <c:showSerName val="0"/>
-              <c:showPercent val="0"/>
-              <c:showBubbleSize val="0"/>
-              <c:extLst>
-                <c:ext xmlns:c15="http://schemas.microsoft.com/office/drawing/2012/chart" uri="{CE6537A1-D6FC-4f65-9D91-7224C49458BB}"/>
-              </c:extLst>
-            </c:dLbl>
-            <c:numFmt formatCode="General" sourceLinked="1"/>
-            <c:spPr>
-              <a:noFill/>
-              <a:ln>
-                <a:noFill/>
-              </a:ln>
-              <a:effectLst/>
-            </c:spPr>
-            <c:txPr>
-              <a:bodyPr rot="0" spcFirstLastPara="0" vertOverflow="ellipsis" vert="horz" wrap="square" lIns="38100" tIns="19050" rIns="38100" bIns="19050" anchor="ctr" anchorCtr="1"/>
-              <a:lstStyle/>
-              <a:p>
-                <a:pPr>
-                  <a:defRPr lang="en-US" sz="1000" b="0" i="0" u="none" strike="noStrike" kern="1200" baseline="0">
-                    <a:solidFill>
-                      <a:schemeClr val="tx1"/>
-                    </a:solidFill>
-                    <a:latin typeface="+mn-lt"/>
-                    <a:ea typeface="+mn-ea"/>
-                    <a:cs typeface="+mn-cs"/>
-                  </a:defRPr>
-                </a:pPr>
-              </a:p>
-            </c:txPr>
-            <c:dLblPos val="outEnd"/>
-            <c:showLegendKey val="0"/>
-            <c:showVal val="1"/>
-            <c:showCatName val="0"/>
-            <c:showSerName val="0"/>
-            <c:showPercent val="0"/>
-            <c:showBubbleSize val="0"/>
-            <c:showLeaderLines val="0"/>
-            <c:extLst>
-              <c:ext xmlns:c15="http://schemas.microsoft.com/office/drawing/2012/chart" uri="{CE6537A1-D6FC-4f65-9D91-7224C49458BB}">
-                <c15:layout/>
-                <c15:showLeaderLines val="0"/>
-                <c15:leaderLines/>
-              </c:ext>
-            </c:extLst>
+            <c:delete val="1"/>
           </c:dLbls>
           <c:cat>
             <c:strRef>
-              <c:f>{"Easy","Medium","Hard"}</c:f>
+              <c:f>Sheet1!$A$2:$A$5</c:f>
               <c:strCache>
-                <c:ptCount val="3"/>
+                <c:ptCount val="4"/>
                 <c:pt idx="0">
                   <c:v>Easy</c:v>
                 </c:pt>
@@ -266,15 +227,15 @@
           </c:cat>
           <c:val>
             <c:numRef>
-              <c:f>{2.5,3.5,4.5}</c:f>
+              <c:f>Sheet1!$B$2:$B$5</c:f>
               <c:numCache>
                 <c:formatCode>General</c:formatCode>
-                <c:ptCount val="3"/>
+                <c:ptCount val="4"/>
                 <c:pt idx="0">
                   <c:v>2.5</c:v>
                 </c:pt>
                 <c:pt idx="1">
-                  <c:v>3.5</c:v>
+                  <c:v>3</c:v>
                 </c:pt>
                 <c:pt idx="2">
                   <c:v>4.5</c:v>
@@ -283,46 +244,161 @@
             </c:numRef>
           </c:val>
         </c:ser>
+        <c:ser>
+          <c:idx val="1"/>
+          <c:order val="1"/>
+          <c:tx>
+            <c:strRef>
+              <c:f>Sheet1!$C$1</c:f>
+              <c:strCache>
+                <c:ptCount val="1"/>
+                <c:pt idx="0">
+                  <c:v/>
+                </c:pt>
+              </c:strCache>
+            </c:strRef>
+          </c:tx>
+          <c:spPr>
+            <a:solidFill>
+              <a:schemeClr val="accent2"/>
+            </a:solidFill>
+            <a:ln>
+              <a:noFill/>
+            </a:ln>
+            <a:effectLst/>
+          </c:spPr>
+          <c:invertIfNegative val="0"/>
+          <c:dLbls>
+            <c:delete val="1"/>
+          </c:dLbls>
+          <c:cat>
+            <c:strRef>
+              <c:f>Sheet1!$A$2:$A$5</c:f>
+              <c:strCache>
+                <c:ptCount val="4"/>
+                <c:pt idx="0">
+                  <c:v>Easy</c:v>
+                </c:pt>
+                <c:pt idx="1">
+                  <c:v>Medium</c:v>
+                </c:pt>
+                <c:pt idx="2">
+                  <c:v>Hard</c:v>
+                </c:pt>
+              </c:strCache>
+            </c:strRef>
+          </c:cat>
+          <c:val>
+            <c:numRef>
+              <c:f>Sheet1!$C$2:$C$5</c:f>
+              <c:numCache>
+                <c:formatCode>General</c:formatCode>
+                <c:ptCount val="4"/>
+              </c:numCache>
+            </c:numRef>
+          </c:val>
+        </c:ser>
+        <c:ser>
+          <c:idx val="2"/>
+          <c:order val="2"/>
+          <c:tx>
+            <c:strRef>
+              <c:f>Sheet1!$D$1</c:f>
+              <c:strCache>
+                <c:ptCount val="1"/>
+                <c:pt idx="0">
+                  <c:v/>
+                </c:pt>
+              </c:strCache>
+            </c:strRef>
+          </c:tx>
+          <c:spPr>
+            <a:solidFill>
+              <a:schemeClr val="accent3"/>
+            </a:solidFill>
+            <a:ln>
+              <a:noFill/>
+            </a:ln>
+            <a:effectLst/>
+          </c:spPr>
+          <c:invertIfNegative val="0"/>
+          <c:dLbls>
+            <c:delete val="1"/>
+          </c:dLbls>
+          <c:cat>
+            <c:strRef>
+              <c:f>Sheet1!$A$2:$A$5</c:f>
+              <c:strCache>
+                <c:ptCount val="4"/>
+                <c:pt idx="0">
+                  <c:v>Easy</c:v>
+                </c:pt>
+                <c:pt idx="1">
+                  <c:v>Medium</c:v>
+                </c:pt>
+                <c:pt idx="2">
+                  <c:v>Hard</c:v>
+                </c:pt>
+              </c:strCache>
+            </c:strRef>
+          </c:cat>
+          <c:val>
+            <c:numRef>
+              <c:f>Sheet1!$D$2:$D$5</c:f>
+              <c:numCache>
+                <c:formatCode>General</c:formatCode>
+                <c:ptCount val="4"/>
+              </c:numCache>
+            </c:numRef>
+          </c:val>
+        </c:ser>
         <c:dLbls>
           <c:showLegendKey val="0"/>
-          <c:showVal val="1"/>
+          <c:showVal val="0"/>
           <c:showCatName val="0"/>
           <c:showSerName val="0"/>
           <c:showPercent val="0"/>
           <c:showBubbleSize val="0"/>
         </c:dLbls>
-        <c:gapWidth val="75"/>
-        <c:axId val="48650112"/>
-        <c:axId val="48672768"/>
+        <c:gapWidth val="246"/>
+        <c:overlap val="-28"/>
+        <c:axId val="305187068"/>
+        <c:axId val="611760474"/>
       </c:barChart>
       <c:catAx>
-        <c:axId val="48650112"/>
+        <c:axId val="305187068"/>
         <c:scaling>
           <c:orientation val="minMax"/>
         </c:scaling>
         <c:delete val="0"/>
         <c:axPos val="b"/>
-        <c:numFmt formatCode="General" sourceLinked="1"/>
         <c:majorTickMark val="none"/>
         <c:minorTickMark val="none"/>
         <c:tickLblPos val="nextTo"/>
         <c:spPr>
-          <a:ln w="9525">
+          <a:noFill/>
+          <a:ln w="9525" cap="flat" cmpd="sng" algn="ctr">
             <a:solidFill>
-              <a:srgbClr val="B8BCC4"/>
+              <a:schemeClr val="tx1">
+                <a:lumMod val="15000"/>
+                <a:lumOff val="85000"/>
+              </a:schemeClr>
             </a:solidFill>
-            <a:prstDash val="solid"/>
             <a:round/>
           </a:ln>
+          <a:effectLst/>
         </c:spPr>
         <c:txPr>
           <a:bodyPr rot="-60000000" spcFirstLastPara="0" vertOverflow="ellipsis" vert="horz" wrap="square" anchor="ctr" anchorCtr="1"/>
           <a:lstStyle/>
           <a:p>
             <a:pPr>
-              <a:defRPr lang="en-US" sz="1200" b="0" i="0" u="none" strike="noStrike" kern="1200" baseline="0">
-                <a:solidFill>
-                  <a:srgbClr val="111111"/>
+              <a:defRPr lang="en-US" sz="900" b="0" i="0" u="none" strike="noStrike" kern="1200" baseline="0">
+                <a:solidFill>
+                  <a:schemeClr val="tx1">
+                    <a:lumMod val="65000"/>
+                    <a:lumOff val="35000"/>
+                  </a:schemeClr>
                 </a:solidFill>
                 <a:latin typeface="+mn-lt"/>
                 <a:ea typeface="+mn-ea"/>
@@ -331,7 +407,7 @@
             </a:pPr>
           </a:p>
         </c:txPr>
-        <c:crossAx val="48672768"/>
+        <c:crossAx val="611760474"/>
         <c:crosses val="autoZero"/>
         <c:auto val="1"/>
         <c:lblAlgn val="ctr"/>
@@ -339,23 +415,23 @@
         <c:noMultiLvlLbl val="0"/>
       </c:catAx>
       <c:valAx>
-        <c:axId val="48672768"/>
+        <c:axId val="611760474"/>
         <c:scaling>
           <c:orientation val="minMax"/>
-          <c:max val="5"/>
-          <c:min val="0"/>
         </c:scaling>
         <c:delete val="0"/>
         <c:axPos val="l"/>
         <c:majorGridlines>
           <c:spPr>
-            <a:ln w="9525">
-              <a:solidFill>
-                <a:srgbClr val="EDEDED"/>
-              </a:solidFill>
-              <a:prstDash val="solid"/>
+            <a:ln w="9525" cap="flat" cmpd="sng" algn="ctr">
+              <a:solidFill>
+                <a:schemeClr val="lt1">
+                  <a:lumMod val="90200"/>
+                </a:schemeClr>
+              </a:solidFill>
               <a:round/>
             </a:ln>
+            <a:effectLst/>
           </c:spPr>
         </c:majorGridlines>
         <c:numFmt formatCode="General" sourceLinked="1"/>
@@ -363,22 +439,23 @@
         <c:minorTickMark val="none"/>
         <c:tickLblPos val="nextTo"/>
         <c:spPr>
-          <a:ln w="0">
-            <a:solidFill>
-              <a:srgbClr val="FFFFFF"/>
-            </a:solidFill>
-            <a:prstDash val="solid"/>
-            <a:round/>
-          </a:ln>
+          <a:noFill/>
+          <a:ln>
+            <a:noFill/>
+          </a:ln>
+          <a:effectLst/>
         </c:spPr>
         <c:txPr>
           <a:bodyPr rot="-60000000" spcFirstLastPara="0" vertOverflow="ellipsis" vert="horz" wrap="square" anchor="ctr" anchorCtr="1"/>
           <a:lstStyle/>
           <a:p>
             <a:pPr>
-              <a:defRPr lang="en-US" sz="1050" b="0" i="0" u="none" strike="noStrike" kern="1200" baseline="0">
-                <a:solidFill>
-                  <a:srgbClr val="5F6368"/>
+              <a:defRPr lang="en-US" sz="900" b="0" i="0" u="none" strike="noStrike" kern="1200" baseline="0">
+                <a:solidFill>
+                  <a:schemeClr val="tx1">
+                    <a:lumMod val="65000"/>
+                    <a:lumOff val="35000"/>
+                  </a:schemeClr>
                 </a:solidFill>
                 <a:latin typeface="+mn-lt"/>
                 <a:ea typeface="+mn-ea"/>
@@ -387,40 +464,59 @@
             </a:pPr>
           </a:p>
         </c:txPr>
-        <c:crossAx val="48650112"/>
+        <c:crossAx val="305187068"/>
         <c:crosses val="autoZero"/>
         <c:crossBetween val="between"/>
-        <c:majorUnit val="1"/>
       </c:valAx>
       <c:spPr>
         <a:noFill/>
-        <a:ln w="0">
-          <a:solidFill>
-            <a:srgbClr val="FFFFFF"/>
-          </a:solidFill>
-          <a:prstDash val="solid"/>
+        <a:ln>
+          <a:noFill/>
         </a:ln>
+        <a:effectLst/>
       </c:spPr>
     </c:plotArea>
+    <c:legend>
+      <c:legendPos val="b"/>
+      <c:layout/>
+      <c:overlay val="0"/>
+      <c:spPr>
+        <a:noFill/>
+        <a:ln>
+          <a:noFill/>
+        </a:ln>
+        <a:effectLst/>
+      </c:spPr>
+      <c:txPr>
+        <a:bodyPr rot="0" spcFirstLastPara="0" vertOverflow="ellipsis" vert="horz" wrap="square" anchor="ctr" anchorCtr="1"/>
+        <a:lstStyle/>
+        <a:p>
+          <a:pPr>
+            <a:defRPr lang="en-US" sz="900" b="0" i="0" u="none" strike="noStrike" kern="1200" baseline="0">
+              <a:solidFill>
+                <a:schemeClr val="tx1">
+                  <a:lumMod val="65000"/>
+                  <a:lumOff val="35000"/>
+                </a:schemeClr>
+              </a:solidFill>
+              <a:latin typeface="+mn-lt"/>
+              <a:ea typeface="+mn-ea"/>
+              <a:cs typeface="+mn-cs"/>
+            </a:defRPr>
+          </a:pPr>
+        </a:p>
+      </c:txPr>
+    </c:legend>
     <c:plotVisOnly val="1"/>
     <c:dispBlanksAs val="gap"/>
     <c:showDLblsOverMax val="0"/>
-    <c:extLst>
-      <c:ext uri="{0b15fc19-7d7d-44ad-8c2d-2c3a37ce22c3}">
-        <chartProps xmlns="https://web.wps.cn/et/2018/main" chartId="{9bfb212a-a5d9-47e0-8fa4-868055738b2f}"/>
-      </c:ext>
-    </c:extLst>
   </c:chart>
   <c:spPr>
-    <a:solidFill>
-      <a:srgbClr val="FFFFFF"/>
-    </a:solidFill>
-    <a:ln w="0">
-      <a:solidFill>
-        <a:srgbClr val="FFFFFF"/>
-      </a:solidFill>
-      <a:prstDash val="solid"/>
+    <a:noFill/>
+    <a:ln>
+      <a:noFill/>
     </a:ln>
+    <a:effectLst/>
   </c:spPr>
   <c:txPr>
     <a:bodyPr/>
@@ -435,6 +531,556 @@
     <c:autoUpdate val="0"/>
   </c:externalData>
 </c:chartSpace>
+</file>
+
+<file path=ppt/charts/colors1.xml><?xml version="1.0" encoding="utf-8"?>
+<cs:colorStyle xmlns:cs="http://schemas.microsoft.com/office/drawing/2012/chartStyle" xmlns:a="http://schemas.openxmlformats.org/drawingml/2006/main" meth="cycle" id="10">
+  <a:schemeClr val="accent1"/>
+  <a:schemeClr val="accent2"/>
+  <a:schemeClr val="accent3"/>
+  <a:schemeClr val="accent4"/>
+  <a:schemeClr val="accent5"/>
+  <a:schemeClr val="accent6"/>
+  <cs:variation/>
+  <cs:variation>
+    <a:lumMod val="60000"/>
+  </cs:variation>
+  <cs:variation>
+    <a:lumMod val="80000"/>
+    <a:lumOff val="20000"/>
+  </cs:variation>
+  <cs:variation>
+    <a:lumMod val="80000"/>
+  </cs:variation>
+  <cs:variation>
+    <a:lumMod val="60000"/>
+    <a:lumOff val="40000"/>
+  </cs:variation>
+  <cs:variation>
+    <a:lumMod val="50000"/>
+  </cs:variation>
+  <cs:variation>
+    <a:lumMod val="70000"/>
+    <a:lumOff val="30000"/>
+  </cs:variation>
+  <cs:variation>
+    <a:lumMod val="70000"/>
+  </cs:variation>
+  <cs:variation>
+    <a:lumMod val="50000"/>
+    <a:lumOff val="50000"/>
+  </cs:variation>
+</cs:colorStyle>
+</file>
+
+<file path=ppt/charts/style1.xml><?xml version="1.0" encoding="utf-8"?>
+<cs:chartStyle xmlns:cs="http://schemas.microsoft.com/office/drawing/2012/chartStyle" xmlns:a="http://schemas.openxmlformats.org/drawingml/2006/main" id="10001">
+  <cs:axisTitle>
+    <cs:lnRef idx="0"/>
+    <cs:fillRef idx="0"/>
+    <cs:effectRef idx="0"/>
+    <cs:fontRef idx="minor">
+      <a:schemeClr val="tx1">
+        <a:lumMod val="65000"/>
+        <a:lumOff val="35000"/>
+      </a:schemeClr>
+    </cs:fontRef>
+    <cs:defRPr sz="1000" kern="1200"/>
+  </cs:axisTitle>
+  <cs:categoryAxis>
+    <cs:lnRef idx="0"/>
+    <cs:fillRef idx="0"/>
+    <cs:effectRef idx="0"/>
+    <cs:fontRef idx="minor">
+      <a:schemeClr val="tx1">
+        <a:lumMod val="65000"/>
+        <a:lumOff val="35000"/>
+      </a:schemeClr>
+    </cs:fontRef>
+    <cs:spPr>
+      <a:ln w="9525" cap="flat" cmpd="sng" algn="ctr">
+        <a:solidFill>
+          <a:schemeClr val="tx1">
+            <a:lumMod val="15000"/>
+            <a:lumOff val="85000"/>
+          </a:schemeClr>
+        </a:solidFill>
+        <a:round/>
+      </a:ln>
+    </cs:spPr>
+    <cs:defRPr sz="900" kern="1200"/>
+  </cs:categoryAxis>
+  <cs:chartArea mods="allowNoFillOverride allowNoLineOverride">
+    <cs:lnRef idx="0"/>
+    <cs:fillRef idx="0"/>
+    <cs:effectRef idx="0"/>
+    <cs:fontRef idx="minor">
+      <a:schemeClr val="tx1"/>
+    </cs:fontRef>
+    <cs:spPr>
+      <a:solidFill>
+        <a:schemeClr val="bg1"/>
+      </a:solidFill>
+      <a:ln w="9525" cap="flat" cmpd="sng" algn="ctr">
+        <a:solidFill>
+          <a:schemeClr val="tx1">
+            <a:lumMod val="15000"/>
+            <a:lumOff val="85000"/>
+          </a:schemeClr>
+        </a:solidFill>
+        <a:round/>
+      </a:ln>
+    </cs:spPr>
+    <cs:defRPr sz="1000" kern="1200"/>
+  </cs:chartArea>
+  <cs:dataLabel>
+    <cs:lnRef idx="0"/>
+    <cs:fillRef idx="0"/>
+    <cs:effectRef idx="0"/>
+    <cs:fontRef idx="minor">
+      <a:schemeClr val="tx1">
+        <a:lumMod val="75000"/>
+        <a:lumOff val="25000"/>
+      </a:schemeClr>
+    </cs:fontRef>
+    <cs:defRPr sz="1000" kern="1200"/>
+  </cs:dataLabel>
+  <cs:dataLabelCallout>
+    <cs:lnRef idx="0"/>
+    <cs:fillRef idx="0"/>
+    <cs:effectRef idx="0"/>
+    <cs:fontRef idx="minor">
+      <a:schemeClr val="dk1">
+        <a:lumMod val="65000"/>
+        <a:lumOff val="35000"/>
+      </a:schemeClr>
+    </cs:fontRef>
+    <cs:spPr>
+      <a:solidFill>
+        <a:schemeClr val="lt1"/>
+      </a:solidFill>
+      <a:ln>
+        <a:solidFill>
+          <a:schemeClr val="dk1">
+            <a:lumMod val="25000"/>
+            <a:lumOff val="75000"/>
+          </a:schemeClr>
+        </a:solidFill>
+      </a:ln>
+    </cs:spPr>
+    <cs:defRPr sz="1000" kern="1200"/>
+    <cs:bodyPr rot="0" spcFirstLastPara="1" vertOverflow="clip" horzOverflow="clip" vert="horz" wrap="square" lIns="36576" tIns="18288" rIns="36576" bIns="18288" anchor="ctr" anchorCtr="1">
+      <a:spAutoFit/>
+    </cs:bodyPr>
+  </cs:dataLabelCallout>
+  <cs:dataPoint>
+    <cs:lnRef idx="0">
+      <cs:styleClr val="auto"/>
+    </cs:lnRef>
+    <cs:fillRef idx="1">
+      <cs:styleClr val="auto"/>
+    </cs:fillRef>
+    <cs:effectRef idx="0"/>
+    <cs:fontRef idx="minor">
+      <a:schemeClr val="dk1"/>
+    </cs:fontRef>
+    <cs:spPr>
+      <a:ln>
+        <a:noFill/>
+      </a:ln>
+      <a:effectLst/>
+    </cs:spPr>
+  </cs:dataPoint>
+  <cs:dataPoint3D>
+    <cs:lnRef idx="0"/>
+    <cs:fillRef idx="1">
+      <cs:styleClr val="auto"/>
+    </cs:fillRef>
+    <cs:effectRef idx="0"/>
+    <cs:fontRef idx="minor">
+      <a:schemeClr val="tx1"/>
+    </cs:fontRef>
+  </cs:dataPoint3D>
+  <cs:dataPointLine>
+    <cs:lnRef idx="0">
+      <cs:styleClr val="auto"/>
+    </cs:lnRef>
+    <cs:fillRef idx="1"/>
+    <cs:effectRef idx="0"/>
+    <cs:fontRef idx="minor">
+      <a:schemeClr val="tx1"/>
+    </cs:fontRef>
+    <cs:spPr>
+      <a:ln w="28575" cap="rnd">
+        <a:solidFill>
+          <a:schemeClr val="phClr"/>
+        </a:solidFill>
+        <a:round/>
+      </a:ln>
+    </cs:spPr>
+  </cs:dataPointLine>
+  <cs:dataPointMarker>
+    <cs:lnRef idx="0">
+      <cs:styleClr val="auto"/>
+    </cs:lnRef>
+    <cs:fillRef idx="1">
+      <cs:styleClr val="auto"/>
+    </cs:fillRef>
+    <cs:effectRef idx="0"/>
+    <cs:fontRef idx="minor">
+      <a:schemeClr val="tx1"/>
+    </cs:fontRef>
+    <cs:spPr>
+      <a:ln w="9525">
+        <a:solidFill>
+          <a:schemeClr val="phClr"/>
+        </a:solidFill>
+      </a:ln>
+    </cs:spPr>
+  </cs:dataPointMarker>
+  <cs:dataPointMarkerLayout symbol="circle" size="5"/>
+  <cs:dataPointWireframe>
+    <cs:lnRef idx="0">
+      <cs:styleClr val="auto"/>
+    </cs:lnRef>
+    <cs:fillRef idx="1"/>
+    <cs:effectRef idx="0"/>
+    <cs:fontRef idx="minor">
+      <a:schemeClr val="tx1"/>
+    </cs:fontRef>
+    <cs:spPr>
+      <a:ln w="9525" cap="rnd">
+        <a:solidFill>
+          <a:schemeClr val="phClr"/>
+        </a:solidFill>
+        <a:round/>
+      </a:ln>
+    </cs:spPr>
+  </cs:dataPointWireframe>
+  <cs:dataTable>
+    <cs:lnRef idx="0"/>
+    <cs:fillRef idx="0"/>
+    <cs:effectRef idx="0"/>
+    <cs:fontRef idx="minor">
+      <a:schemeClr val="tx1">
+        <a:lumMod val="65000"/>
+        <a:lumOff val="35000"/>
+      </a:schemeClr>
+    </cs:fontRef>
+    <cs:spPr>
+      <a:noFill/>
+      <a:ln w="9525" cap="flat" cmpd="sng" algn="ctr">
+        <a:solidFill>
+          <a:schemeClr val="tx1">
+            <a:lumMod val="15000"/>
+            <a:lumOff val="85000"/>
+          </a:schemeClr>
+        </a:solidFill>
+        <a:round/>
+      </a:ln>
+    </cs:spPr>
+    <cs:defRPr sz="900" kern="1200"/>
+  </cs:dataTable>
+  <cs:downBar>
+    <cs:lnRef idx="0"/>
+    <cs:fillRef idx="0"/>
+    <cs:effectRef idx="0"/>
+    <cs:fontRef idx="minor">
+      <a:schemeClr val="dk1"/>
+    </cs:fontRef>
+    <cs:spPr>
+      <a:solidFill>
+        <a:schemeClr val="dk1">
+          <a:lumMod val="65000"/>
+          <a:lumOff val="35000"/>
+        </a:schemeClr>
+      </a:solidFill>
+      <a:ln w="9525">
+        <a:solidFill>
+          <a:schemeClr val="tx1">
+            <a:lumMod val="65000"/>
+            <a:lumOff val="35000"/>
+          </a:schemeClr>
+        </a:solidFill>
+      </a:ln>
+    </cs:spPr>
+  </cs:downBar>
+  <cs:dropLine>
+    <cs:lnRef idx="0"/>
+    <cs:fillRef idx="0"/>
+    <cs:effectRef idx="0"/>
+    <cs:fontRef idx="minor">
+      <a:schemeClr val="tx1"/>
+    </cs:fontRef>
+    <cs:spPr>
+      <a:ln w="9525" cap="flat" cmpd="sng" algn="ctr">
+        <a:solidFill>
+          <a:schemeClr val="tx1">
+            <a:lumMod val="35000"/>
+            <a:lumOff val="65000"/>
+          </a:schemeClr>
+        </a:solidFill>
+        <a:round/>
+      </a:ln>
+    </cs:spPr>
+  </cs:dropLine>
+  <cs:errorBar>
+    <cs:lnRef idx="0"/>
+    <cs:fillRef idx="0"/>
+    <cs:effectRef idx="0"/>
+    <cs:fontRef idx="minor">
+      <a:schemeClr val="tx1"/>
+    </cs:fontRef>
+    <cs:spPr>
+      <a:ln w="9525" cap="flat" cmpd="sng" algn="ctr">
+        <a:solidFill>
+          <a:schemeClr val="tx1">
+            <a:lumMod val="65000"/>
+            <a:lumOff val="35000"/>
+          </a:schemeClr>
+        </a:solidFill>
+        <a:round/>
+      </a:ln>
+    </cs:spPr>
+  </cs:errorBar>
+  <cs:floor>
+    <cs:lnRef idx="0"/>
+    <cs:fillRef idx="0"/>
+    <cs:effectRef idx="0"/>
+    <cs:fontRef idx="minor">
+      <a:schemeClr val="tx1"/>
+    </cs:fontRef>
+    <cs:spPr>
+      <a:noFill/>
+      <a:ln>
+        <a:noFill/>
+      </a:ln>
+    </cs:spPr>
+  </cs:floor>
+  <cs:gridlineMajor>
+    <cs:lnRef idx="0"/>
+    <cs:fillRef idx="0"/>
+    <cs:effectRef idx="0"/>
+    <cs:fontRef idx="minor">
+      <a:schemeClr val="tx1"/>
+    </cs:fontRef>
+    <cs:spPr>
+      <a:ln w="9525" cap="flat" cmpd="sng" algn="ctr">
+        <a:solidFill>
+          <a:schemeClr val="lt1">
+            <a:lumMod val="90200"/>
+          </a:schemeClr>
+        </a:solidFill>
+        <a:round/>
+      </a:ln>
+    </cs:spPr>
+  </cs:gridlineMajor>
+  <cs:gridlineMinor>
+    <cs:lnRef idx="0"/>
+    <cs:fillRef idx="0"/>
+    <cs:effectRef idx="0"/>
+    <cs:fontRef idx="minor">
+      <a:schemeClr val="tx1"/>
+    </cs:fontRef>
+    <cs:spPr>
+      <a:ln w="9525" cap="flat" cmpd="sng" algn="ctr">
+        <a:solidFill>
+          <a:schemeClr val="tx1">
+            <a:lumMod val="5000"/>
+            <a:lumOff val="95000"/>
+          </a:schemeClr>
+        </a:solidFill>
+        <a:round/>
+      </a:ln>
+    </cs:spPr>
+  </cs:gridlineMinor>
+  <cs:hiLoLine>
+    <cs:lnRef idx="0"/>
+    <cs:fillRef idx="0"/>
+    <cs:effectRef idx="0"/>
+    <cs:fontRef idx="minor">
+      <a:schemeClr val="tx1"/>
+    </cs:fontRef>
+    <cs:spPr>
+      <a:ln w="9525" cap="flat" cmpd="sng" algn="ctr">
+        <a:solidFill>
+          <a:schemeClr val="tx1">
+            <a:lumMod val="75000"/>
+            <a:lumOff val="25000"/>
+          </a:schemeClr>
+        </a:solidFill>
+        <a:round/>
+      </a:ln>
+    </cs:spPr>
+  </cs:hiLoLine>
+  <cs:leaderLine>
+    <cs:lnRef idx="0"/>
+    <cs:fillRef idx="0"/>
+    <cs:effectRef idx="0"/>
+    <cs:fontRef idx="minor">
+      <a:schemeClr val="tx1"/>
+    </cs:fontRef>
+    <cs:spPr>
+      <a:ln w="9525" cap="flat" cmpd="sng" algn="ctr">
+        <a:solidFill>
+          <a:schemeClr val="tx1">
+            <a:lumMod val="35000"/>
+            <a:lumOff val="65000"/>
+          </a:schemeClr>
+        </a:solidFill>
+        <a:round/>
+      </a:ln>
+    </cs:spPr>
+  </cs:leaderLine>
+  <cs:legend>
+    <cs:lnRef idx="0"/>
+    <cs:fillRef idx="0"/>
+    <cs:effectRef idx="0"/>
+    <cs:fontRef idx="minor">
+      <a:schemeClr val="tx1">
+        <a:lumMod val="65000"/>
+        <a:lumOff val="35000"/>
+      </a:schemeClr>
+    </cs:fontRef>
+    <cs:defRPr sz="900" kern="1200"/>
+  </cs:legend>
+  <cs:plotArea mods="allowNoFillOverride allowNoLineOverride">
+    <cs:lnRef idx="0"/>
+    <cs:fillRef idx="0"/>
+    <cs:effectRef idx="0"/>
+    <cs:fontRef idx="minor">
+      <a:schemeClr val="tx1"/>
+    </cs:fontRef>
+  </cs:plotArea>
+  <cs:plotArea3D mods="allowNoFillOverride allowNoLineOverride">
+    <cs:lnRef idx="0"/>
+    <cs:fillRef idx="0"/>
+    <cs:effectRef idx="0"/>
+    <cs:fontRef idx="minor">
+      <a:schemeClr val="tx1"/>
+    </cs:fontRef>
+  </cs:plotArea3D>
+  <cs:seriesAxis>
+    <cs:lnRef idx="0"/>
+    <cs:fillRef idx="0"/>
+    <cs:effectRef idx="0"/>
+    <cs:fontRef idx="minor">
+      <a:schemeClr val="tx1">
+        <a:lumMod val="65000"/>
+        <a:lumOff val="35000"/>
+      </a:schemeClr>
+    </cs:fontRef>
+    <cs:defRPr sz="900" kern="1200"/>
+  </cs:seriesAxis>
+  <cs:seriesLine>
+    <cs:lnRef idx="0"/>
+    <cs:fillRef idx="0"/>
+    <cs:effectRef idx="0"/>
+    <cs:fontRef idx="minor">
+      <a:schemeClr val="tx1"/>
+    </cs:fontRef>
+    <cs:spPr>
+      <a:ln w="9525" cap="flat" cmpd="sng" algn="ctr">
+        <a:solidFill>
+          <a:schemeClr val="tx1">
+            <a:lumMod val="35000"/>
+            <a:lumOff val="65000"/>
+          </a:schemeClr>
+        </a:solidFill>
+        <a:round/>
+      </a:ln>
+    </cs:spPr>
+  </cs:seriesLine>
+  <cs:title>
+    <cs:lnRef idx="0"/>
+    <cs:fillRef idx="0"/>
+    <cs:effectRef idx="0"/>
+    <cs:fontRef idx="minor">
+      <a:schemeClr val="tx1">
+        <a:lumMod val="75000"/>
+        <a:lumOff val="25000"/>
+      </a:schemeClr>
+    </cs:fontRef>
+    <cs:defRPr sz="1400" b="1" kern="1200" baseline="0"/>
+  </cs:title>
+  <cs:trendline>
+    <cs:lnRef idx="0">
+      <cs:styleClr val="auto"/>
+    </cs:lnRef>
+    <cs:fillRef idx="0"/>
+    <cs:effectRef idx="0"/>
+    <cs:fontRef idx="minor">
+      <a:schemeClr val="tx1"/>
+    </cs:fontRef>
+    <cs:spPr>
+      <a:ln w="19050" cap="rnd">
+        <a:solidFill>
+          <a:schemeClr val="phClr"/>
+        </a:solidFill>
+        <a:prstDash val="sysDot"/>
+      </a:ln>
+    </cs:spPr>
+  </cs:trendline>
+  <cs:trendlineLabel>
+    <cs:lnRef idx="0"/>
+    <cs:fillRef idx="0"/>
+    <cs:effectRef idx="0"/>
+    <cs:fontRef idx="minor">
+      <a:schemeClr val="tx1">
+        <a:lumMod val="65000"/>
+        <a:lumOff val="35000"/>
+      </a:schemeClr>
+    </cs:fontRef>
+    <cs:defRPr sz="900" kern="1200"/>
+  </cs:trendlineLabel>
+  <cs:upBar>
+    <cs:lnRef idx="0"/>
+    <cs:fillRef idx="0"/>
+    <cs:effectRef idx="0"/>
+    <cs:fontRef idx="minor">
+      <a:schemeClr val="dk1"/>
+    </cs:fontRef>
+    <cs:spPr>
+      <a:solidFill>
+        <a:schemeClr val="lt1"/>
+      </a:solidFill>
+      <a:ln w="9525">
+        <a:solidFill>
+          <a:schemeClr val="tx1">
+            <a:lumMod val="15000"/>
+            <a:lumOff val="85000"/>
+          </a:schemeClr>
+        </a:solidFill>
+      </a:ln>
+    </cs:spPr>
+  </cs:upBar>
+  <cs:valueAxis>
+    <cs:lnRef idx="0"/>
+    <cs:fillRef idx="0"/>
+    <cs:effectRef idx="0"/>
+    <cs:fontRef idx="minor">
+      <a:schemeClr val="tx1">
+        <a:lumMod val="65000"/>
+        <a:lumOff val="35000"/>
+      </a:schemeClr>
+    </cs:fontRef>
+    <cs:defRPr sz="900" kern="1200"/>
+  </cs:valueAxis>
+  <cs:wall>
+    <cs:lnRef idx="0"/>
+    <cs:fillRef idx="0"/>
+    <cs:effectRef idx="0"/>
+    <cs:fontRef idx="minor">
+      <a:schemeClr val="tx1"/>
+    </cs:fontRef>
+    <cs:spPr>
+      <a:noFill/>
+      <a:ln>
+        <a:noFill/>
+      </a:ln>
+    </cs:spPr>
+  </cs:wall>
+</cs:chartStyle>
 </file>
 
 <file path=ppt/notesMasters/notesMaster1.xml><?xml version="1.0" encoding="utf-8"?>
@@ -5304,15 +5950,615 @@
           </a:p>
         </p:txBody>
       </p:sp>
+      <p:sp>
+        <p:nvSpPr>
+          <p:cNvPr id="5" name="Rectangle 4"/>
+          <p:cNvSpPr>
+            <a:spLocks noGrp="1"/>
+          </p:cNvSpPr>
+          <p:nvPr/>
+        </p:nvSpPr>
+        <p:spPr>
+          <a:xfrm>
+            <a:off x="762000" y="5695950"/>
+            <a:ext cx="5619750" cy="266700"/>
+          </a:xfrm>
+          <a:prstGeom prst="rect">
+            <a:avLst/>
+          </a:prstGeom>
+          <a:noFill/>
+          <a:ln w="0">
+            <a:noFill/>
+            <a:prstDash val="solid"/>
+          </a:ln>
+        </p:spPr>
+        <p:txBody>
+          <a:bodyPr anchor="t">
+            <a:noAutofit/>
+          </a:bodyPr>
+          <a:lstStyle/>
+          <a:p>
+            <a:pPr algn="ctr">
+              <a:defRPr sz="1350" b="0">
+                <a:solidFill>
+                  <a:srgbClr val="5F6368"/>
+                </a:solidFill>
+                <a:latin typeface="Arial" panose="020B0604020202020204"/>
+                <a:ea typeface="Arial" panose="020B0604020202020204"/>
+                <a:cs typeface="Arial" panose="020B0604020202020204"/>
+              </a:defRPr>
+            </a:pPr>
+            <a:r>
+              <a:rPr sz="1350" b="0">
+                <a:solidFill>
+                  <a:srgbClr val="5F6368"/>
+                </a:solidFill>
+                <a:latin typeface="Arial" panose="020B0604020202020204"/>
+                <a:ea typeface="Arial" panose="020B0604020202020204"/>
+                <a:cs typeface="Arial" panose="020B0604020202020204"/>
+              </a:rPr>
+              <a:t>Bước trung bình tăng theo độ khó</a:t>
+            </a:r>
+            <a:endParaRPr sz="1350" b="0">
+              <a:solidFill>
+                <a:srgbClr val="5F6368"/>
+              </a:solidFill>
+              <a:latin typeface="Arial" panose="020B0604020202020204"/>
+              <a:ea typeface="Arial" panose="020B0604020202020204"/>
+              <a:cs typeface="Arial" panose="020B0604020202020204"/>
+            </a:endParaRPr>
+          </a:p>
+        </p:txBody>
+      </p:sp>
+      <p:sp>
+        <p:nvSpPr>
+          <p:cNvPr id="6" name="Rectangle 5"/>
+          <p:cNvSpPr>
+            <a:spLocks noGrp="1"/>
+          </p:cNvSpPr>
+          <p:nvPr/>
+        </p:nvSpPr>
+        <p:spPr>
+          <a:xfrm>
+            <a:off x="7467600" y="1981200"/>
+            <a:ext cx="3619500" cy="876300"/>
+          </a:xfrm>
+          <a:prstGeom prst="rect">
+            <a:avLst/>
+          </a:prstGeom>
+          <a:noFill/>
+          <a:ln w="0">
+            <a:noFill/>
+            <a:prstDash val="solid"/>
+          </a:ln>
+        </p:spPr>
+        <p:txBody>
+          <a:bodyPr anchor="t">
+            <a:noAutofit/>
+          </a:bodyPr>
+          <a:lstStyle/>
+          <a:p>
+            <a:pPr algn="l">
+              <a:defRPr sz="4950" b="1">
+                <a:solidFill>
+                  <a:srgbClr val="3D8DFF"/>
+                </a:solidFill>
+                <a:latin typeface="Arial" panose="020B0604020202020204"/>
+                <a:ea typeface="Arial" panose="020B0604020202020204"/>
+                <a:cs typeface="Arial" panose="020B0604020202020204"/>
+              </a:defRPr>
+            </a:pPr>
+            <a:r>
+              <a:rPr sz="4950" b="1">
+                <a:solidFill>
+                  <a:srgbClr val="3D8DFF"/>
+                </a:solidFill>
+                <a:latin typeface="Arial" panose="020B0604020202020204"/>
+                <a:ea typeface="Arial" panose="020B0604020202020204"/>
+                <a:cs typeface="Arial" panose="020B0604020202020204"/>
+              </a:rPr>
+              <a:t>10/10</a:t>
+            </a:r>
+            <a:endParaRPr sz="4950" b="1">
+              <a:solidFill>
+                <a:srgbClr val="3D8DFF"/>
+              </a:solidFill>
+              <a:latin typeface="Arial" panose="020B0604020202020204"/>
+              <a:ea typeface="Arial" panose="020B0604020202020204"/>
+              <a:cs typeface="Arial" panose="020B0604020202020204"/>
+            </a:endParaRPr>
+          </a:p>
+        </p:txBody>
+      </p:sp>
+      <p:sp>
+        <p:nvSpPr>
+          <p:cNvPr id="7" name="Rectangle 6"/>
+          <p:cNvSpPr>
+            <a:spLocks noGrp="1"/>
+          </p:cNvSpPr>
+          <p:nvPr/>
+        </p:nvSpPr>
+        <p:spPr>
+          <a:xfrm>
+            <a:off x="7467600" y="2857500"/>
+            <a:ext cx="3619500" cy="323850"/>
+          </a:xfrm>
+          <a:prstGeom prst="rect">
+            <a:avLst/>
+          </a:prstGeom>
+          <a:noFill/>
+          <a:ln w="0">
+            <a:noFill/>
+            <a:prstDash val="solid"/>
+          </a:ln>
+        </p:spPr>
+        <p:txBody>
+          <a:bodyPr anchor="t">
+            <a:noAutofit/>
+          </a:bodyPr>
+          <a:lstStyle/>
+          <a:p>
+            <a:pPr algn="l">
+              <a:defRPr sz="1650" b="1">
+                <a:solidFill>
+                  <a:srgbClr val="111111"/>
+                </a:solidFill>
+                <a:latin typeface="Arial" panose="020B0604020202020204"/>
+                <a:ea typeface="Arial" panose="020B0604020202020204"/>
+                <a:cs typeface="Arial" panose="020B0604020202020204"/>
+              </a:defRPr>
+            </a:pPr>
+            <a:r>
+              <a:rPr sz="1650" b="1">
+                <a:solidFill>
+                  <a:srgbClr val="111111"/>
+                </a:solidFill>
+                <a:latin typeface="Arial" panose="020B0604020202020204"/>
+                <a:ea typeface="Arial" panose="020B0604020202020204"/>
+                <a:cs typeface="Arial" panose="020B0604020202020204"/>
+              </a:rPr>
+              <a:t>success rate = 100%</a:t>
+            </a:r>
+            <a:endParaRPr sz="1650" b="1">
+              <a:solidFill>
+                <a:srgbClr val="111111"/>
+              </a:solidFill>
+              <a:latin typeface="Arial" panose="020B0604020202020204"/>
+              <a:ea typeface="Arial" panose="020B0604020202020204"/>
+              <a:cs typeface="Arial" panose="020B0604020202020204"/>
+            </a:endParaRPr>
+          </a:p>
+        </p:txBody>
+      </p:sp>
+      <p:cxnSp>
+        <p:nvCxnSpPr>
+          <p:cNvPr id="23" name="Straight Arrow Connector 22"/>
+          <p:cNvCxnSpPr/>
+          <p:nvPr/>
+        </p:nvCxnSpPr>
+        <p:spPr>
+          <a:xfrm>
+            <a:off x="7467600" y="3467100"/>
+            <a:ext cx="3619500" cy="953"/>
+          </a:xfrm>
+          <a:prstGeom prst="straightConnector1">
+            <a:avLst/>
+          </a:prstGeom>
+          <a:ln w="9525">
+            <a:solidFill>
+              <a:srgbClr val="B8BCC4"/>
+            </a:solidFill>
+            <a:prstDash val="solid"/>
+          </a:ln>
+        </p:spPr>
+      </p:cxnSp>
+      <p:sp>
+        <p:nvSpPr>
+          <p:cNvPr id="9" name="Rectangle 8"/>
+          <p:cNvSpPr>
+            <a:spLocks noGrp="1"/>
+          </p:cNvSpPr>
+          <p:nvPr/>
+        </p:nvSpPr>
+        <p:spPr>
+          <a:xfrm>
+            <a:off x="7467600" y="3771900"/>
+            <a:ext cx="1524000" cy="514350"/>
+          </a:xfrm>
+          <a:prstGeom prst="rect">
+            <a:avLst/>
+          </a:prstGeom>
+          <a:noFill/>
+          <a:ln w="0">
+            <a:noFill/>
+            <a:prstDash val="solid"/>
+          </a:ln>
+        </p:spPr>
+        <p:txBody>
+          <a:bodyPr anchor="t">
+            <a:noAutofit/>
+          </a:bodyPr>
+          <a:lstStyle/>
+          <a:p>
+            <a:pPr algn="l">
+              <a:defRPr sz="3000" b="1">
+                <a:solidFill>
+                  <a:srgbClr val="111111"/>
+                </a:solidFill>
+                <a:latin typeface="Arial" panose="020B0604020202020204"/>
+                <a:ea typeface="Arial" panose="020B0604020202020204"/>
+                <a:cs typeface="Arial" panose="020B0604020202020204"/>
+              </a:defRPr>
+            </a:pPr>
+            <a:r>
+              <a:rPr sz="3000" b="1">
+                <a:solidFill>
+                  <a:srgbClr val="111111"/>
+                </a:solidFill>
+                <a:latin typeface="Arial" panose="020B0604020202020204"/>
+                <a:ea typeface="Arial" panose="020B0604020202020204"/>
+                <a:cs typeface="Arial" panose="020B0604020202020204"/>
+              </a:rPr>
+              <a:t>3</a:t>
+            </a:r>
+            <a:r>
+              <a:rPr lang="en-US" sz="3000" b="1">
+                <a:solidFill>
+                  <a:srgbClr val="111111"/>
+                </a:solidFill>
+                <a:latin typeface="Arial" panose="020B0604020202020204"/>
+                <a:ea typeface="Arial" panose="020B0604020202020204"/>
+                <a:cs typeface="Arial" panose="020B0604020202020204"/>
+              </a:rPr>
+              <a:t>1</a:t>
+            </a:r>
+            <a:endParaRPr lang="en-US" sz="3000" b="1">
+              <a:solidFill>
+                <a:srgbClr val="111111"/>
+              </a:solidFill>
+              <a:latin typeface="Arial" panose="020B0604020202020204"/>
+              <a:ea typeface="Arial" panose="020B0604020202020204"/>
+              <a:cs typeface="Arial" panose="020B0604020202020204"/>
+            </a:endParaRPr>
+          </a:p>
+        </p:txBody>
+      </p:sp>
+      <p:sp>
+        <p:nvSpPr>
+          <p:cNvPr id="10" name="Rectangle 9"/>
+          <p:cNvSpPr>
+            <a:spLocks noGrp="1"/>
+          </p:cNvSpPr>
+          <p:nvPr/>
+        </p:nvSpPr>
+        <p:spPr>
+          <a:xfrm>
+            <a:off x="7467600" y="4305300"/>
+            <a:ext cx="1524000" cy="285750"/>
+          </a:xfrm>
+          <a:prstGeom prst="rect">
+            <a:avLst/>
+          </a:prstGeom>
+          <a:noFill/>
+          <a:ln w="0">
+            <a:noFill/>
+            <a:prstDash val="solid"/>
+          </a:ln>
+        </p:spPr>
+        <p:txBody>
+          <a:bodyPr anchor="t">
+            <a:noAutofit/>
+          </a:bodyPr>
+          <a:lstStyle/>
+          <a:p>
+            <a:pPr algn="l">
+              <a:defRPr sz="1275" b="0">
+                <a:solidFill>
+                  <a:srgbClr val="5F6368"/>
+                </a:solidFill>
+                <a:latin typeface="Arial" panose="020B0604020202020204"/>
+                <a:ea typeface="Arial" panose="020B0604020202020204"/>
+                <a:cs typeface="Arial" panose="020B0604020202020204"/>
+              </a:defRPr>
+            </a:pPr>
+            <a:r>
+              <a:rPr sz="1275" b="0">
+                <a:solidFill>
+                  <a:srgbClr val="5F6368"/>
+                </a:solidFill>
+                <a:latin typeface="Arial" panose="020B0604020202020204"/>
+                <a:ea typeface="Arial" panose="020B0604020202020204"/>
+                <a:cs typeface="Arial" panose="020B0604020202020204"/>
+              </a:rPr>
+              <a:t>tổng số bước</a:t>
+            </a:r>
+            <a:endParaRPr sz="1275" b="0">
+              <a:solidFill>
+                <a:srgbClr val="5F6368"/>
+              </a:solidFill>
+              <a:latin typeface="Arial" panose="020B0604020202020204"/>
+              <a:ea typeface="Arial" panose="020B0604020202020204"/>
+              <a:cs typeface="Arial" panose="020B0604020202020204"/>
+            </a:endParaRPr>
+          </a:p>
+        </p:txBody>
+      </p:sp>
+      <p:sp>
+        <p:nvSpPr>
+          <p:cNvPr id="11" name="Rectangle 10"/>
+          <p:cNvSpPr>
+            <a:spLocks noGrp="1"/>
+          </p:cNvSpPr>
+          <p:nvPr/>
+        </p:nvSpPr>
+        <p:spPr>
+          <a:xfrm>
+            <a:off x="9448800" y="3771900"/>
+            <a:ext cx="1809750" cy="514350"/>
+          </a:xfrm>
+          <a:prstGeom prst="rect">
+            <a:avLst/>
+          </a:prstGeom>
+          <a:noFill/>
+          <a:ln w="0">
+            <a:noFill/>
+            <a:prstDash val="solid"/>
+          </a:ln>
+        </p:spPr>
+        <p:txBody>
+          <a:bodyPr anchor="t">
+            <a:noAutofit/>
+          </a:bodyPr>
+          <a:lstStyle/>
+          <a:p>
+            <a:pPr algn="l">
+              <a:defRPr sz="3000" b="1">
+                <a:solidFill>
+                  <a:srgbClr val="111111"/>
+                </a:solidFill>
+                <a:latin typeface="Arial" panose="020B0604020202020204"/>
+                <a:ea typeface="Arial" panose="020B0604020202020204"/>
+                <a:cs typeface="Arial" panose="020B0604020202020204"/>
+              </a:defRPr>
+            </a:pPr>
+            <a:r>
+              <a:rPr lang="en-US" sz="3000" b="1">
+                <a:solidFill>
+                  <a:srgbClr val="111111"/>
+                </a:solidFill>
+                <a:latin typeface="Arial" panose="020B0604020202020204"/>
+                <a:ea typeface="Arial" panose="020B0604020202020204"/>
+                <a:cs typeface="Arial" panose="020B0604020202020204"/>
+              </a:rPr>
+              <a:t>32,394</a:t>
+            </a:r>
+            <a:endParaRPr lang="en-US" sz="3000" b="1">
+              <a:solidFill>
+                <a:srgbClr val="111111"/>
+              </a:solidFill>
+              <a:latin typeface="Arial" panose="020B0604020202020204"/>
+              <a:ea typeface="Arial" panose="020B0604020202020204"/>
+              <a:cs typeface="Arial" panose="020B0604020202020204"/>
+            </a:endParaRPr>
+          </a:p>
+        </p:txBody>
+      </p:sp>
+      <p:sp>
+        <p:nvSpPr>
+          <p:cNvPr id="12" name="Rectangle 11"/>
+          <p:cNvSpPr>
+            <a:spLocks noGrp="1"/>
+          </p:cNvSpPr>
+          <p:nvPr/>
+        </p:nvSpPr>
+        <p:spPr>
+          <a:xfrm>
+            <a:off x="9448800" y="4305300"/>
+            <a:ext cx="1809750" cy="285750"/>
+          </a:xfrm>
+          <a:prstGeom prst="rect">
+            <a:avLst/>
+          </a:prstGeom>
+          <a:noFill/>
+          <a:ln w="0">
+            <a:noFill/>
+            <a:prstDash val="solid"/>
+          </a:ln>
+        </p:spPr>
+        <p:txBody>
+          <a:bodyPr anchor="t">
+            <a:noAutofit/>
+          </a:bodyPr>
+          <a:lstStyle/>
+          <a:p>
+            <a:pPr algn="l">
+              <a:defRPr sz="1275" b="0">
+                <a:solidFill>
+                  <a:srgbClr val="5F6368"/>
+                </a:solidFill>
+                <a:latin typeface="Arial" panose="020B0604020202020204"/>
+                <a:ea typeface="Arial" panose="020B0604020202020204"/>
+                <a:cs typeface="Arial" panose="020B0604020202020204"/>
+              </a:defRPr>
+            </a:pPr>
+            <a:r>
+              <a:rPr sz="1275" b="0">
+                <a:solidFill>
+                  <a:srgbClr val="5F6368"/>
+                </a:solidFill>
+                <a:latin typeface="Arial" panose="020B0604020202020204"/>
+                <a:ea typeface="Arial" panose="020B0604020202020204"/>
+                <a:cs typeface="Arial" panose="020B0604020202020204"/>
+              </a:rPr>
+              <a:t>tokens xấp xỉ</a:t>
+            </a:r>
+            <a:endParaRPr sz="1275" b="0">
+              <a:solidFill>
+                <a:srgbClr val="5F6368"/>
+              </a:solidFill>
+              <a:latin typeface="Arial" panose="020B0604020202020204"/>
+              <a:ea typeface="Arial" panose="020B0604020202020204"/>
+              <a:cs typeface="Arial" panose="020B0604020202020204"/>
+            </a:endParaRPr>
+          </a:p>
+        </p:txBody>
+      </p:sp>
+      <p:sp>
+        <p:nvSpPr>
+          <p:cNvPr id="13" name="Rectangle 12"/>
+          <p:cNvSpPr>
+            <a:spLocks noGrp="1"/>
+          </p:cNvSpPr>
+          <p:nvPr/>
+        </p:nvSpPr>
+        <p:spPr>
+          <a:xfrm>
+            <a:off x="7467600" y="5010150"/>
+            <a:ext cx="3810000" cy="876300"/>
+          </a:xfrm>
+          <a:prstGeom prst="rect">
+            <a:avLst/>
+          </a:prstGeom>
+          <a:solidFill>
+            <a:srgbClr val="F7F7F7"/>
+          </a:solidFill>
+          <a:ln w="9525">
+            <a:solidFill>
+              <a:srgbClr val="B8BCC4"/>
+            </a:solidFill>
+            <a:prstDash val="solid"/>
+          </a:ln>
+        </p:spPr>
+      </p:sp>
+      <p:sp>
+        <p:nvSpPr>
+          <p:cNvPr id="14" name="Rectangle 13"/>
+          <p:cNvSpPr>
+            <a:spLocks noGrp="1"/>
+          </p:cNvSpPr>
+          <p:nvPr/>
+        </p:nvSpPr>
+        <p:spPr>
+          <a:xfrm>
+            <a:off x="7696200" y="5181600"/>
+            <a:ext cx="762000" cy="247650"/>
+          </a:xfrm>
+          <a:prstGeom prst="rect">
+            <a:avLst/>
+          </a:prstGeom>
+          <a:noFill/>
+          <a:ln w="0">
+            <a:noFill/>
+            <a:prstDash val="solid"/>
+          </a:ln>
+        </p:spPr>
+        <p:txBody>
+          <a:bodyPr anchor="t">
+            <a:noAutofit/>
+          </a:bodyPr>
+          <a:lstStyle/>
+          <a:p>
+            <a:pPr algn="l">
+              <a:defRPr sz="1350" b="1">
+                <a:solidFill>
+                  <a:srgbClr val="B66A00"/>
+                </a:solidFill>
+                <a:latin typeface="Arial" panose="020B0604020202020204"/>
+                <a:ea typeface="Arial" panose="020B0604020202020204"/>
+                <a:cs typeface="Arial" panose="020B0604020202020204"/>
+              </a:defRPr>
+            </a:pPr>
+            <a:r>
+              <a:rPr sz="1350" b="1">
+                <a:solidFill>
+                  <a:srgbClr val="B66A00"/>
+                </a:solidFill>
+                <a:latin typeface="Arial" panose="020B0604020202020204"/>
+                <a:ea typeface="Arial" panose="020B0604020202020204"/>
+                <a:cs typeface="Arial" panose="020B0604020202020204"/>
+              </a:rPr>
+              <a:t>Lưu ý</a:t>
+            </a:r>
+            <a:endParaRPr sz="1350" b="1">
+              <a:solidFill>
+                <a:srgbClr val="B66A00"/>
+              </a:solidFill>
+              <a:latin typeface="Arial" panose="020B0604020202020204"/>
+              <a:ea typeface="Arial" panose="020B0604020202020204"/>
+              <a:cs typeface="Arial" panose="020B0604020202020204"/>
+            </a:endParaRPr>
+          </a:p>
+        </p:txBody>
+      </p:sp>
+      <p:sp>
+        <p:nvSpPr>
+          <p:cNvPr id="15" name="Rectangle 14"/>
+          <p:cNvSpPr>
+            <a:spLocks noGrp="1"/>
+          </p:cNvSpPr>
+          <p:nvPr/>
+        </p:nvSpPr>
+        <p:spPr>
+          <a:xfrm>
+            <a:off x="8458200" y="5162550"/>
+            <a:ext cx="2571750" cy="552450"/>
+          </a:xfrm>
+          <a:prstGeom prst="rect">
+            <a:avLst/>
+          </a:prstGeom>
+          <a:noFill/>
+          <a:ln w="0">
+            <a:noFill/>
+            <a:prstDash val="solid"/>
+          </a:ln>
+        </p:spPr>
+        <p:txBody>
+          <a:bodyPr anchor="t">
+            <a:noAutofit/>
+          </a:bodyPr>
+          <a:lstStyle/>
+          <a:p>
+            <a:pPr algn="l">
+              <a:defRPr sz="1200" b="0">
+                <a:solidFill>
+                  <a:srgbClr val="5F6368"/>
+                </a:solidFill>
+                <a:latin typeface="Arial" panose="020B0604020202020204"/>
+                <a:ea typeface="Arial" panose="020B0604020202020204"/>
+                <a:cs typeface="Arial" panose="020B0604020202020204"/>
+              </a:defRPr>
+            </a:pPr>
+            <a:r>
+              <a:rPr sz="1200" b="0">
+                <a:solidFill>
+                  <a:srgbClr val="5F6368"/>
+                </a:solidFill>
+                <a:latin typeface="Arial" panose="020B0604020202020204"/>
+                <a:ea typeface="Arial" panose="020B0604020202020204"/>
+                <a:cs typeface="Arial" panose="020B0604020202020204"/>
+              </a:rPr>
+              <a:t>Kết quả của một lần chạy, temperature 0.1; LLM có tính không tất định.</a:t>
+            </a:r>
+            <a:endParaRPr sz="1200" b="0">
+              <a:solidFill>
+                <a:srgbClr val="5F6368"/>
+              </a:solidFill>
+              <a:latin typeface="Arial" panose="020B0604020202020204"/>
+              <a:ea typeface="Arial" panose="020B0604020202020204"/>
+              <a:cs typeface="Arial" panose="020B0604020202020204"/>
+            </a:endParaRPr>
+          </a:p>
+        </p:txBody>
+      </p:sp>
       <p:graphicFrame>
         <p:nvGraphicFramePr>
-          <p:cNvPr id="19" name="Chart"/>
+          <p:cNvPr id="17" name="Chart 16"/>
           <p:cNvGraphicFramePr/>
           <p:nvPr/>
         </p:nvGraphicFramePr>
         <p:xfrm>
-          <a:off x="551180" y="1916430"/>
-          <a:ext cx="6191250" cy="3714750"/>
+          <a:off x="335280" y="1537335"/>
+          <a:ext cx="6839585" cy="3959860"/>
         </p:xfrm>
         <a:graphic>
           <a:graphicData uri="http://schemas.openxmlformats.org/drawingml/2006/chart">
@@ -5320,606 +6566,6 @@
           </a:graphicData>
         </a:graphic>
       </p:graphicFrame>
-      <p:sp>
-        <p:nvSpPr>
-          <p:cNvPr id="5" name="Rectangle 4"/>
-          <p:cNvSpPr>
-            <a:spLocks noGrp="1"/>
-          </p:cNvSpPr>
-          <p:nvPr/>
-        </p:nvSpPr>
-        <p:spPr>
-          <a:xfrm>
-            <a:off x="762000" y="5695950"/>
-            <a:ext cx="5619750" cy="266700"/>
-          </a:xfrm>
-          <a:prstGeom prst="rect">
-            <a:avLst/>
-          </a:prstGeom>
-          <a:noFill/>
-          <a:ln w="0">
-            <a:noFill/>
-            <a:prstDash val="solid"/>
-          </a:ln>
-        </p:spPr>
-        <p:txBody>
-          <a:bodyPr anchor="t">
-            <a:noAutofit/>
-          </a:bodyPr>
-          <a:lstStyle/>
-          <a:p>
-            <a:pPr algn="ctr">
-              <a:defRPr sz="1350" b="0">
-                <a:solidFill>
-                  <a:srgbClr val="5F6368"/>
-                </a:solidFill>
-                <a:latin typeface="Arial" panose="020B0604020202020204"/>
-                <a:ea typeface="Arial" panose="020B0604020202020204"/>
-                <a:cs typeface="Arial" panose="020B0604020202020204"/>
-              </a:defRPr>
-            </a:pPr>
-            <a:r>
-              <a:rPr sz="1350" b="0">
-                <a:solidFill>
-                  <a:srgbClr val="5F6368"/>
-                </a:solidFill>
-                <a:latin typeface="Arial" panose="020B0604020202020204"/>
-                <a:ea typeface="Arial" panose="020B0604020202020204"/>
-                <a:cs typeface="Arial" panose="020B0604020202020204"/>
-              </a:rPr>
-              <a:t>Bước trung bình tăng theo độ khó</a:t>
-            </a:r>
-            <a:endParaRPr sz="1350" b="0">
-              <a:solidFill>
-                <a:srgbClr val="5F6368"/>
-              </a:solidFill>
-              <a:latin typeface="Arial" panose="020B0604020202020204"/>
-              <a:ea typeface="Arial" panose="020B0604020202020204"/>
-              <a:cs typeface="Arial" panose="020B0604020202020204"/>
-            </a:endParaRPr>
-          </a:p>
-        </p:txBody>
-      </p:sp>
-      <p:sp>
-        <p:nvSpPr>
-          <p:cNvPr id="6" name="Rectangle 5"/>
-          <p:cNvSpPr>
-            <a:spLocks noGrp="1"/>
-          </p:cNvSpPr>
-          <p:nvPr/>
-        </p:nvSpPr>
-        <p:spPr>
-          <a:xfrm>
-            <a:off x="7467600" y="1981200"/>
-            <a:ext cx="3619500" cy="876300"/>
-          </a:xfrm>
-          <a:prstGeom prst="rect">
-            <a:avLst/>
-          </a:prstGeom>
-          <a:noFill/>
-          <a:ln w="0">
-            <a:noFill/>
-            <a:prstDash val="solid"/>
-          </a:ln>
-        </p:spPr>
-        <p:txBody>
-          <a:bodyPr anchor="t">
-            <a:noAutofit/>
-          </a:bodyPr>
-          <a:lstStyle/>
-          <a:p>
-            <a:pPr algn="l">
-              <a:defRPr sz="4950" b="1">
-                <a:solidFill>
-                  <a:srgbClr val="3D8DFF"/>
-                </a:solidFill>
-                <a:latin typeface="Arial" panose="020B0604020202020204"/>
-                <a:ea typeface="Arial" panose="020B0604020202020204"/>
-                <a:cs typeface="Arial" panose="020B0604020202020204"/>
-              </a:defRPr>
-            </a:pPr>
-            <a:r>
-              <a:rPr sz="4950" b="1">
-                <a:solidFill>
-                  <a:srgbClr val="3D8DFF"/>
-                </a:solidFill>
-                <a:latin typeface="Arial" panose="020B0604020202020204"/>
-                <a:ea typeface="Arial" panose="020B0604020202020204"/>
-                <a:cs typeface="Arial" panose="020B0604020202020204"/>
-              </a:rPr>
-              <a:t>10/10</a:t>
-            </a:r>
-            <a:endParaRPr sz="4950" b="1">
-              <a:solidFill>
-                <a:srgbClr val="3D8DFF"/>
-              </a:solidFill>
-              <a:latin typeface="Arial" panose="020B0604020202020204"/>
-              <a:ea typeface="Arial" panose="020B0604020202020204"/>
-              <a:cs typeface="Arial" panose="020B0604020202020204"/>
-            </a:endParaRPr>
-          </a:p>
-        </p:txBody>
-      </p:sp>
-      <p:sp>
-        <p:nvSpPr>
-          <p:cNvPr id="7" name="Rectangle 6"/>
-          <p:cNvSpPr>
-            <a:spLocks noGrp="1"/>
-          </p:cNvSpPr>
-          <p:nvPr/>
-        </p:nvSpPr>
-        <p:spPr>
-          <a:xfrm>
-            <a:off x="7467600" y="2857500"/>
-            <a:ext cx="3619500" cy="323850"/>
-          </a:xfrm>
-          <a:prstGeom prst="rect">
-            <a:avLst/>
-          </a:prstGeom>
-          <a:noFill/>
-          <a:ln w="0">
-            <a:noFill/>
-            <a:prstDash val="solid"/>
-          </a:ln>
-        </p:spPr>
-        <p:txBody>
-          <a:bodyPr anchor="t">
-            <a:noAutofit/>
-          </a:bodyPr>
-          <a:lstStyle/>
-          <a:p>
-            <a:pPr algn="l">
-              <a:defRPr sz="1650" b="1">
-                <a:solidFill>
-                  <a:srgbClr val="111111"/>
-                </a:solidFill>
-                <a:latin typeface="Arial" panose="020B0604020202020204"/>
-                <a:ea typeface="Arial" panose="020B0604020202020204"/>
-                <a:cs typeface="Arial" panose="020B0604020202020204"/>
-              </a:defRPr>
-            </a:pPr>
-            <a:r>
-              <a:rPr sz="1650" b="1">
-                <a:solidFill>
-                  <a:srgbClr val="111111"/>
-                </a:solidFill>
-                <a:latin typeface="Arial" panose="020B0604020202020204"/>
-                <a:ea typeface="Arial" panose="020B0604020202020204"/>
-                <a:cs typeface="Arial" panose="020B0604020202020204"/>
-              </a:rPr>
-              <a:t>success rate = 100%</a:t>
-            </a:r>
-            <a:endParaRPr sz="1650" b="1">
-              <a:solidFill>
-                <a:srgbClr val="111111"/>
-              </a:solidFill>
-              <a:latin typeface="Arial" panose="020B0604020202020204"/>
-              <a:ea typeface="Arial" panose="020B0604020202020204"/>
-              <a:cs typeface="Arial" panose="020B0604020202020204"/>
-            </a:endParaRPr>
-          </a:p>
-        </p:txBody>
-      </p:sp>
-      <p:cxnSp>
-        <p:nvCxnSpPr>
-          <p:cNvPr id="23" name="Straight Arrow Connector 22"/>
-          <p:cNvCxnSpPr/>
-          <p:nvPr/>
-        </p:nvCxnSpPr>
-        <p:spPr>
-          <a:xfrm>
-            <a:off x="7467600" y="3467100"/>
-            <a:ext cx="3619500" cy="953"/>
-          </a:xfrm>
-          <a:prstGeom prst="straightConnector1">
-            <a:avLst/>
-          </a:prstGeom>
-          <a:ln w="9525">
-            <a:solidFill>
-              <a:srgbClr val="B8BCC4"/>
-            </a:solidFill>
-            <a:prstDash val="solid"/>
-          </a:ln>
-        </p:spPr>
-      </p:cxnSp>
-      <p:sp>
-        <p:nvSpPr>
-          <p:cNvPr id="9" name="Rectangle 8"/>
-          <p:cNvSpPr>
-            <a:spLocks noGrp="1"/>
-          </p:cNvSpPr>
-          <p:nvPr/>
-        </p:nvSpPr>
-        <p:spPr>
-          <a:xfrm>
-            <a:off x="7467600" y="3771900"/>
-            <a:ext cx="1524000" cy="514350"/>
-          </a:xfrm>
-          <a:prstGeom prst="rect">
-            <a:avLst/>
-          </a:prstGeom>
-          <a:noFill/>
-          <a:ln w="0">
-            <a:noFill/>
-            <a:prstDash val="solid"/>
-          </a:ln>
-        </p:spPr>
-        <p:txBody>
-          <a:bodyPr anchor="t">
-            <a:noAutofit/>
-          </a:bodyPr>
-          <a:lstStyle/>
-          <a:p>
-            <a:pPr algn="l">
-              <a:defRPr sz="3000" b="1">
-                <a:solidFill>
-                  <a:srgbClr val="111111"/>
-                </a:solidFill>
-                <a:latin typeface="Arial" panose="020B0604020202020204"/>
-                <a:ea typeface="Arial" panose="020B0604020202020204"/>
-                <a:cs typeface="Arial" panose="020B0604020202020204"/>
-              </a:defRPr>
-            </a:pPr>
-            <a:r>
-              <a:rPr sz="3000" b="1">
-                <a:solidFill>
-                  <a:srgbClr val="111111"/>
-                </a:solidFill>
-                <a:latin typeface="Arial" panose="020B0604020202020204"/>
-                <a:ea typeface="Arial" panose="020B0604020202020204"/>
-                <a:cs typeface="Arial" panose="020B0604020202020204"/>
-              </a:rPr>
-              <a:t>3</a:t>
-            </a:r>
-            <a:r>
-              <a:rPr lang="en-US" sz="3000" b="1">
-                <a:solidFill>
-                  <a:srgbClr val="111111"/>
-                </a:solidFill>
-                <a:latin typeface="Arial" panose="020B0604020202020204"/>
-                <a:ea typeface="Arial" panose="020B0604020202020204"/>
-                <a:cs typeface="Arial" panose="020B0604020202020204"/>
-              </a:rPr>
-              <a:t>1</a:t>
-            </a:r>
-            <a:endParaRPr lang="en-US" sz="3000" b="1">
-              <a:solidFill>
-                <a:srgbClr val="111111"/>
-              </a:solidFill>
-              <a:latin typeface="Arial" panose="020B0604020202020204"/>
-              <a:ea typeface="Arial" panose="020B0604020202020204"/>
-              <a:cs typeface="Arial" panose="020B0604020202020204"/>
-            </a:endParaRPr>
-          </a:p>
-        </p:txBody>
-      </p:sp>
-      <p:sp>
-        <p:nvSpPr>
-          <p:cNvPr id="10" name="Rectangle 9"/>
-          <p:cNvSpPr>
-            <a:spLocks noGrp="1"/>
-          </p:cNvSpPr>
-          <p:nvPr/>
-        </p:nvSpPr>
-        <p:spPr>
-          <a:xfrm>
-            <a:off x="7467600" y="4305300"/>
-            <a:ext cx="1524000" cy="285750"/>
-          </a:xfrm>
-          <a:prstGeom prst="rect">
-            <a:avLst/>
-          </a:prstGeom>
-          <a:noFill/>
-          <a:ln w="0">
-            <a:noFill/>
-            <a:prstDash val="solid"/>
-          </a:ln>
-        </p:spPr>
-        <p:txBody>
-          <a:bodyPr anchor="t">
-            <a:noAutofit/>
-          </a:bodyPr>
-          <a:lstStyle/>
-          <a:p>
-            <a:pPr algn="l">
-              <a:defRPr sz="1275" b="0">
-                <a:solidFill>
-                  <a:srgbClr val="5F6368"/>
-                </a:solidFill>
-                <a:latin typeface="Arial" panose="020B0604020202020204"/>
-                <a:ea typeface="Arial" panose="020B0604020202020204"/>
-                <a:cs typeface="Arial" panose="020B0604020202020204"/>
-              </a:defRPr>
-            </a:pPr>
-            <a:r>
-              <a:rPr sz="1275" b="0">
-                <a:solidFill>
-                  <a:srgbClr val="5F6368"/>
-                </a:solidFill>
-                <a:latin typeface="Arial" panose="020B0604020202020204"/>
-                <a:ea typeface="Arial" panose="020B0604020202020204"/>
-                <a:cs typeface="Arial" panose="020B0604020202020204"/>
-              </a:rPr>
-              <a:t>tổng số bước</a:t>
-            </a:r>
-            <a:endParaRPr sz="1275" b="0">
-              <a:solidFill>
-                <a:srgbClr val="5F6368"/>
-              </a:solidFill>
-              <a:latin typeface="Arial" panose="020B0604020202020204"/>
-              <a:ea typeface="Arial" panose="020B0604020202020204"/>
-              <a:cs typeface="Arial" panose="020B0604020202020204"/>
-            </a:endParaRPr>
-          </a:p>
-        </p:txBody>
-      </p:sp>
-      <p:sp>
-        <p:nvSpPr>
-          <p:cNvPr id="11" name="Rectangle 10"/>
-          <p:cNvSpPr>
-            <a:spLocks noGrp="1"/>
-          </p:cNvSpPr>
-          <p:nvPr/>
-        </p:nvSpPr>
-        <p:spPr>
-          <a:xfrm>
-            <a:off x="9448800" y="3771900"/>
-            <a:ext cx="1809750" cy="514350"/>
-          </a:xfrm>
-          <a:prstGeom prst="rect">
-            <a:avLst/>
-          </a:prstGeom>
-          <a:noFill/>
-          <a:ln w="0">
-            <a:noFill/>
-            <a:prstDash val="solid"/>
-          </a:ln>
-        </p:spPr>
-        <p:txBody>
-          <a:bodyPr anchor="t">
-            <a:noAutofit/>
-          </a:bodyPr>
-          <a:lstStyle/>
-          <a:p>
-            <a:pPr algn="l">
-              <a:defRPr sz="3000" b="1">
-                <a:solidFill>
-                  <a:srgbClr val="111111"/>
-                </a:solidFill>
-                <a:latin typeface="Arial" panose="020B0604020202020204"/>
-                <a:ea typeface="Arial" panose="020B0604020202020204"/>
-                <a:cs typeface="Arial" panose="020B0604020202020204"/>
-              </a:defRPr>
-            </a:pPr>
-            <a:r>
-              <a:rPr lang="en-US" sz="3000" b="1">
-                <a:solidFill>
-                  <a:srgbClr val="111111"/>
-                </a:solidFill>
-                <a:latin typeface="Arial" panose="020B0604020202020204"/>
-                <a:ea typeface="Arial" panose="020B0604020202020204"/>
-                <a:cs typeface="Arial" panose="020B0604020202020204"/>
-              </a:rPr>
-              <a:t>32,394</a:t>
-            </a:r>
-            <a:endParaRPr lang="en-US" sz="3000" b="1">
-              <a:solidFill>
-                <a:srgbClr val="111111"/>
-              </a:solidFill>
-              <a:latin typeface="Arial" panose="020B0604020202020204"/>
-              <a:ea typeface="Arial" panose="020B0604020202020204"/>
-              <a:cs typeface="Arial" panose="020B0604020202020204"/>
-            </a:endParaRPr>
-          </a:p>
-        </p:txBody>
-      </p:sp>
-      <p:sp>
-        <p:nvSpPr>
-          <p:cNvPr id="12" name="Rectangle 11"/>
-          <p:cNvSpPr>
-            <a:spLocks noGrp="1"/>
-          </p:cNvSpPr>
-          <p:nvPr/>
-        </p:nvSpPr>
-        <p:spPr>
-          <a:xfrm>
-            <a:off x="9448800" y="4305300"/>
-            <a:ext cx="1809750" cy="285750"/>
-          </a:xfrm>
-          <a:prstGeom prst="rect">
-            <a:avLst/>
-          </a:prstGeom>
-          <a:noFill/>
-          <a:ln w="0">
-            <a:noFill/>
-            <a:prstDash val="solid"/>
-          </a:ln>
-        </p:spPr>
-        <p:txBody>
-          <a:bodyPr anchor="t">
-            <a:noAutofit/>
-          </a:bodyPr>
-          <a:lstStyle/>
-          <a:p>
-            <a:pPr algn="l">
-              <a:defRPr sz="1275" b="0">
-                <a:solidFill>
-                  <a:srgbClr val="5F6368"/>
-                </a:solidFill>
-                <a:latin typeface="Arial" panose="020B0604020202020204"/>
-                <a:ea typeface="Arial" panose="020B0604020202020204"/>
-                <a:cs typeface="Arial" panose="020B0604020202020204"/>
-              </a:defRPr>
-            </a:pPr>
-            <a:r>
-              <a:rPr sz="1275" b="0">
-                <a:solidFill>
-                  <a:srgbClr val="5F6368"/>
-                </a:solidFill>
-                <a:latin typeface="Arial" panose="020B0604020202020204"/>
-                <a:ea typeface="Arial" panose="020B0604020202020204"/>
-                <a:cs typeface="Arial" panose="020B0604020202020204"/>
-              </a:rPr>
-              <a:t>tokens xấp xỉ</a:t>
-            </a:r>
-            <a:endParaRPr sz="1275" b="0">
-              <a:solidFill>
-                <a:srgbClr val="5F6368"/>
-              </a:solidFill>
-              <a:latin typeface="Arial" panose="020B0604020202020204"/>
-              <a:ea typeface="Arial" panose="020B0604020202020204"/>
-              <a:cs typeface="Arial" panose="020B0604020202020204"/>
-            </a:endParaRPr>
-          </a:p>
-        </p:txBody>
-      </p:sp>
-      <p:sp>
-        <p:nvSpPr>
-          <p:cNvPr id="13" name="Rectangle 12"/>
-          <p:cNvSpPr>
-            <a:spLocks noGrp="1"/>
-          </p:cNvSpPr>
-          <p:nvPr/>
-        </p:nvSpPr>
-        <p:spPr>
-          <a:xfrm>
-            <a:off x="7467600" y="5010150"/>
-            <a:ext cx="3810000" cy="876300"/>
-          </a:xfrm>
-          <a:prstGeom prst="rect">
-            <a:avLst/>
-          </a:prstGeom>
-          <a:solidFill>
-            <a:srgbClr val="F7F7F7"/>
-          </a:solidFill>
-          <a:ln w="9525">
-            <a:solidFill>
-              <a:srgbClr val="B8BCC4"/>
-            </a:solidFill>
-            <a:prstDash val="solid"/>
-          </a:ln>
-        </p:spPr>
-      </p:sp>
-      <p:sp>
-        <p:nvSpPr>
-          <p:cNvPr id="14" name="Rectangle 13"/>
-          <p:cNvSpPr>
-            <a:spLocks noGrp="1"/>
-          </p:cNvSpPr>
-          <p:nvPr/>
-        </p:nvSpPr>
-        <p:spPr>
-          <a:xfrm>
-            <a:off x="7696200" y="5181600"/>
-            <a:ext cx="762000" cy="247650"/>
-          </a:xfrm>
-          <a:prstGeom prst="rect">
-            <a:avLst/>
-          </a:prstGeom>
-          <a:noFill/>
-          <a:ln w="0">
-            <a:noFill/>
-            <a:prstDash val="solid"/>
-          </a:ln>
-        </p:spPr>
-        <p:txBody>
-          <a:bodyPr anchor="t">
-            <a:noAutofit/>
-          </a:bodyPr>
-          <a:lstStyle/>
-          <a:p>
-            <a:pPr algn="l">
-              <a:defRPr sz="1350" b="1">
-                <a:solidFill>
-                  <a:srgbClr val="B66A00"/>
-                </a:solidFill>
-                <a:latin typeface="Arial" panose="020B0604020202020204"/>
-                <a:ea typeface="Arial" panose="020B0604020202020204"/>
-                <a:cs typeface="Arial" panose="020B0604020202020204"/>
-              </a:defRPr>
-            </a:pPr>
-            <a:r>
-              <a:rPr sz="1350" b="1">
-                <a:solidFill>
-                  <a:srgbClr val="B66A00"/>
-                </a:solidFill>
-                <a:latin typeface="Arial" panose="020B0604020202020204"/>
-                <a:ea typeface="Arial" panose="020B0604020202020204"/>
-                <a:cs typeface="Arial" panose="020B0604020202020204"/>
-              </a:rPr>
-              <a:t>Lưu ý</a:t>
-            </a:r>
-            <a:endParaRPr sz="1350" b="1">
-              <a:solidFill>
-                <a:srgbClr val="B66A00"/>
-              </a:solidFill>
-              <a:latin typeface="Arial" panose="020B0604020202020204"/>
-              <a:ea typeface="Arial" panose="020B0604020202020204"/>
-              <a:cs typeface="Arial" panose="020B0604020202020204"/>
-            </a:endParaRPr>
-          </a:p>
-        </p:txBody>
-      </p:sp>
-      <p:sp>
-        <p:nvSpPr>
-          <p:cNvPr id="15" name="Rectangle 14"/>
-          <p:cNvSpPr>
-            <a:spLocks noGrp="1"/>
-          </p:cNvSpPr>
-          <p:nvPr/>
-        </p:nvSpPr>
-        <p:spPr>
-          <a:xfrm>
-            <a:off x="8458200" y="5162550"/>
-            <a:ext cx="2571750" cy="552450"/>
-          </a:xfrm>
-          <a:prstGeom prst="rect">
-            <a:avLst/>
-          </a:prstGeom>
-          <a:noFill/>
-          <a:ln w="0">
-            <a:noFill/>
-            <a:prstDash val="solid"/>
-          </a:ln>
-        </p:spPr>
-        <p:txBody>
-          <a:bodyPr anchor="t">
-            <a:noAutofit/>
-          </a:bodyPr>
-          <a:lstStyle/>
-          <a:p>
-            <a:pPr algn="l">
-              <a:defRPr sz="1200" b="0">
-                <a:solidFill>
-                  <a:srgbClr val="5F6368"/>
-                </a:solidFill>
-                <a:latin typeface="Arial" panose="020B0604020202020204"/>
-                <a:ea typeface="Arial" panose="020B0604020202020204"/>
-                <a:cs typeface="Arial" panose="020B0604020202020204"/>
-              </a:defRPr>
-            </a:pPr>
-            <a:r>
-              <a:rPr sz="1200" b="0">
-                <a:solidFill>
-                  <a:srgbClr val="5F6368"/>
-                </a:solidFill>
-                <a:latin typeface="Arial" panose="020B0604020202020204"/>
-                <a:ea typeface="Arial" panose="020B0604020202020204"/>
-                <a:cs typeface="Arial" panose="020B0604020202020204"/>
-              </a:rPr>
-              <a:t>Kết quả của một lần chạy, temperature 0.1; LLM có tính không tất định.</a:t>
-            </a:r>
-            <a:endParaRPr sz="1200" b="0">
-              <a:solidFill>
-                <a:srgbClr val="5F6368"/>
-              </a:solidFill>
-              <a:latin typeface="Arial" panose="020B0604020202020204"/>
-              <a:ea typeface="Arial" panose="020B0604020202020204"/>
-              <a:cs typeface="Arial" panose="020B0604020202020204"/>
-            </a:endParaRPr>
-          </a:p>
-        </p:txBody>
-      </p:sp>
     </p:spTree>
   </p:cSld>
   <p:clrMapOvr>

</xml_diff>

<commit_message>
update youtube link and slide
</commit_message>
<xml_diff>
--- a/docs/Slide.pptx
+++ b/docs/Slide.pptx
@@ -510,6 +510,11 @@
     <c:plotVisOnly val="1"/>
     <c:dispBlanksAs val="gap"/>
     <c:showDLblsOverMax val="0"/>
+    <c:extLst>
+      <c:ext uri="{0b15fc19-7d7d-44ad-8c2d-2c3a37ce22c3}">
+        <chartProps xmlns="https://web.wps.cn/et/2018/main" chartId="{a8d13f1b-d487-41ec-9c15-eb7b677e64f6}"/>
+      </c:ext>
+    </c:extLst>
   </c:chart>
   <c:spPr>
     <a:noFill/>
@@ -12612,6 +12617,17 @@
               </a:defRPr>
             </a:pPr>
             <a:r>
+              <a:rPr lang="en-US" sz="1500" b="0">
+                <a:solidFill>
+                  <a:srgbClr val="5F6368"/>
+                </a:solidFill>
+                <a:latin typeface="Arial" panose="020B0604020202020204"/>
+                <a:ea typeface="Arial" panose="020B0604020202020204"/>
+                <a:cs typeface="Arial" panose="020B0604020202020204"/>
+              </a:rPr>
+              <a:t>8</a:t>
+            </a:r>
+            <a:r>
               <a:rPr sz="1500" b="0">
                 <a:solidFill>
                   <a:srgbClr val="5F6368"/>
@@ -12620,7 +12636,7 @@
                 <a:ea typeface="Arial" panose="020B0604020202020204"/>
                 <a:cs typeface="Arial" panose="020B0604020202020204"/>
               </a:rPr>
-              <a:t>5 lớp triển khai</a:t>
+              <a:t> lớp triển khai</a:t>
             </a:r>
             <a:endParaRPr sz="1500" b="0">
               <a:solidFill>

</xml_diff>